<commit_message>
Vendor Profile- working with admin vendor profile (part - 1)
</commit_message>
<xml_diff>
--- a/.lessons/58 Backend Product And Related Features/6 Vendor Profile- working with admin vendor profile (part - 1)/1.pptx
+++ b/.lessons/58 Backend Product And Related Features/6 Vendor Profile- working with admin vendor profile (part - 1)/1.pptx
@@ -8,6 +8,28 @@
     <p:sldId id="413" r:id="rId2"/>
     <p:sldId id="414" r:id="rId3"/>
     <p:sldId id="400" r:id="rId4"/>
+    <p:sldId id="415" r:id="rId5"/>
+    <p:sldId id="416" r:id="rId6"/>
+    <p:sldId id="417" r:id="rId7"/>
+    <p:sldId id="418" r:id="rId8"/>
+    <p:sldId id="419" r:id="rId9"/>
+    <p:sldId id="420" r:id="rId10"/>
+    <p:sldId id="421" r:id="rId11"/>
+    <p:sldId id="422" r:id="rId12"/>
+    <p:sldId id="423" r:id="rId13"/>
+    <p:sldId id="424" r:id="rId14"/>
+    <p:sldId id="428" r:id="rId15"/>
+    <p:sldId id="429" r:id="rId16"/>
+    <p:sldId id="430" r:id="rId17"/>
+    <p:sldId id="431" r:id="rId18"/>
+    <p:sldId id="432" r:id="rId19"/>
+    <p:sldId id="425" r:id="rId20"/>
+    <p:sldId id="426" r:id="rId21"/>
+    <p:sldId id="433" r:id="rId22"/>
+    <p:sldId id="434" r:id="rId23"/>
+    <p:sldId id="435" r:id="rId24"/>
+    <p:sldId id="436" r:id="rId25"/>
+    <p:sldId id="427" r:id="rId26"/>
   </p:sldIdLst>
   <p:sldSz cx="12192000" cy="6858000"/>
   <p:notesSz cx="6858000" cy="9144000"/>
@@ -261,7 +283,7 @@
           <a:p>
             <a:fld id="{3E102D2E-813C-461C-9963-687A650C48C0}" type="datetimeFigureOut">
               <a:rPr lang="en-US" smtClean="0"/>
-              <a:t>6/26/2025</a:t>
+              <a:t>9/8/2025</a:t>
             </a:fld>
             <a:endParaRPr lang="en-US"/>
           </a:p>
@@ -459,7 +481,7 @@
           <a:p>
             <a:fld id="{3E102D2E-813C-461C-9963-687A650C48C0}" type="datetimeFigureOut">
               <a:rPr lang="en-US" smtClean="0"/>
-              <a:t>6/26/2025</a:t>
+              <a:t>9/8/2025</a:t>
             </a:fld>
             <a:endParaRPr lang="en-US"/>
           </a:p>
@@ -667,7 +689,7 @@
           <a:p>
             <a:fld id="{3E102D2E-813C-461C-9963-687A650C48C0}" type="datetimeFigureOut">
               <a:rPr lang="en-US" smtClean="0"/>
-              <a:t>6/26/2025</a:t>
+              <a:t>9/8/2025</a:t>
             </a:fld>
             <a:endParaRPr lang="en-US"/>
           </a:p>
@@ -865,7 +887,7 @@
           <a:p>
             <a:fld id="{3E102D2E-813C-461C-9963-687A650C48C0}" type="datetimeFigureOut">
               <a:rPr lang="en-US" smtClean="0"/>
-              <a:t>6/26/2025</a:t>
+              <a:t>9/8/2025</a:t>
             </a:fld>
             <a:endParaRPr lang="en-US"/>
           </a:p>
@@ -1140,7 +1162,7 @@
           <a:p>
             <a:fld id="{3E102D2E-813C-461C-9963-687A650C48C0}" type="datetimeFigureOut">
               <a:rPr lang="en-US" smtClean="0"/>
-              <a:t>6/26/2025</a:t>
+              <a:t>9/8/2025</a:t>
             </a:fld>
             <a:endParaRPr lang="en-US"/>
           </a:p>
@@ -1405,7 +1427,7 @@
           <a:p>
             <a:fld id="{3E102D2E-813C-461C-9963-687A650C48C0}" type="datetimeFigureOut">
               <a:rPr lang="en-US" smtClean="0"/>
-              <a:t>6/26/2025</a:t>
+              <a:t>9/8/2025</a:t>
             </a:fld>
             <a:endParaRPr lang="en-US"/>
           </a:p>
@@ -1817,7 +1839,7 @@
           <a:p>
             <a:fld id="{3E102D2E-813C-461C-9963-687A650C48C0}" type="datetimeFigureOut">
               <a:rPr lang="en-US" smtClean="0"/>
-              <a:t>6/26/2025</a:t>
+              <a:t>9/8/2025</a:t>
             </a:fld>
             <a:endParaRPr lang="en-US"/>
           </a:p>
@@ -1958,7 +1980,7 @@
           <a:p>
             <a:fld id="{3E102D2E-813C-461C-9963-687A650C48C0}" type="datetimeFigureOut">
               <a:rPr lang="en-US" smtClean="0"/>
-              <a:t>6/26/2025</a:t>
+              <a:t>9/8/2025</a:t>
             </a:fld>
             <a:endParaRPr lang="en-US"/>
           </a:p>
@@ -2071,7 +2093,7 @@
           <a:p>
             <a:fld id="{3E102D2E-813C-461C-9963-687A650C48C0}" type="datetimeFigureOut">
               <a:rPr lang="en-US" smtClean="0"/>
-              <a:t>6/26/2025</a:t>
+              <a:t>9/8/2025</a:t>
             </a:fld>
             <a:endParaRPr lang="en-US"/>
           </a:p>
@@ -2382,7 +2404,7 @@
           <a:p>
             <a:fld id="{3E102D2E-813C-461C-9963-687A650C48C0}" type="datetimeFigureOut">
               <a:rPr lang="en-US" smtClean="0"/>
-              <a:t>6/26/2025</a:t>
+              <a:t>9/8/2025</a:t>
             </a:fld>
             <a:endParaRPr lang="en-US"/>
           </a:p>
@@ -2670,7 +2692,7 @@
           <a:p>
             <a:fld id="{3E102D2E-813C-461C-9963-687A650C48C0}" type="datetimeFigureOut">
               <a:rPr lang="en-US" smtClean="0"/>
-              <a:t>6/26/2025</a:t>
+              <a:t>9/8/2025</a:t>
             </a:fld>
             <a:endParaRPr lang="en-US"/>
           </a:p>
@@ -2911,7 +2933,7 @@
           <a:p>
             <a:fld id="{3E102D2E-813C-461C-9963-687A650C48C0}" type="datetimeFigureOut">
               <a:rPr lang="en-US" smtClean="0"/>
-              <a:t>6/26/2025</a:t>
+              <a:t>9/8/2025</a:t>
             </a:fld>
             <a:endParaRPr lang="en-US"/>
           </a:p>
@@ -3348,6 +3370,1220 @@
         </p:nvSpPr>
         <p:spPr>
           <a:xfrm>
+            <a:off x="217713" y="190392"/>
+            <a:ext cx="11756571" cy="355354"/>
+          </a:xfrm>
+          <a:prstGeom prst="rect">
+            <a:avLst/>
+          </a:prstGeom>
+          <a:noFill/>
+        </p:spPr>
+        <p:txBody>
+          <a:bodyPr wrap="square">
+            <a:spAutoFit/>
+          </a:bodyPr>
+          <a:lstStyle/>
+          <a:p>
+            <a:pPr>
+              <a:lnSpc>
+                <a:spcPct val="150000"/>
+              </a:lnSpc>
+              <a:buNone/>
+            </a:pPr>
+            <a:r>
+              <a:rPr lang="en-US" altLang="en-US" sz="1300">
+                <a:latin typeface="Arial" panose="020B0604020202020204" pitchFamily="34" charset="0"/>
+              </a:rPr>
+              <a:t>Vendor s</a:t>
+            </a:r>
+            <a:r>
+              <a:rPr lang="az-Latn-AZ" altLang="en-US" sz="1300">
+                <a:latin typeface="Arial" panose="020B0604020202020204" pitchFamily="34" charset="0"/>
+              </a:rPr>
+              <a:t>əhifəsini yığacağıq bu dərs.</a:t>
+            </a:r>
+            <a:endParaRPr kumimoji="0" lang="en-US" altLang="en-US" sz="1300" b="0" i="0" u="none" strike="noStrike" cap="none" normalizeH="0" baseline="0">
+              <a:ln>
+                <a:noFill/>
+              </a:ln>
+              <a:solidFill>
+                <a:schemeClr val="tx1"/>
+              </a:solidFill>
+              <a:effectLst/>
+              <a:latin typeface="Arial" panose="020B0604020202020204" pitchFamily="34" charset="0"/>
+            </a:endParaRPr>
+          </a:p>
+        </p:txBody>
+      </p:sp>
+      <p:pic>
+        <p:nvPicPr>
+          <p:cNvPr id="4" name="Picture 3">
+            <a:extLst>
+              <a:ext uri="{FF2B5EF4-FFF2-40B4-BE49-F238E27FC236}">
+                <a16:creationId xmlns:a16="http://schemas.microsoft.com/office/drawing/2014/main" id="{C6CC8C42-B722-8A80-B84B-577DC3E456A6}"/>
+              </a:ext>
+            </a:extLst>
+          </p:cNvPr>
+          <p:cNvPicPr>
+            <a:picLocks noChangeAspect="1"/>
+          </p:cNvPicPr>
+          <p:nvPr/>
+        </p:nvPicPr>
+        <p:blipFill>
+          <a:blip r:embed="rId2"/>
+          <a:stretch>
+            <a:fillRect/>
+          </a:stretch>
+        </p:blipFill>
+        <p:spPr>
+          <a:xfrm>
+            <a:off x="-1" y="698100"/>
+            <a:ext cx="12192000" cy="6159900"/>
+          </a:xfrm>
+          <a:prstGeom prst="rect">
+            <a:avLst/>
+          </a:prstGeom>
+        </p:spPr>
+      </p:pic>
+    </p:spTree>
+    <p:extLst>
+      <p:ext uri="{BB962C8B-B14F-4D97-AF65-F5344CB8AC3E}">
+        <p14:creationId xmlns:p14="http://schemas.microsoft.com/office/powerpoint/2010/main" val="3863838039"/>
+      </p:ext>
+    </p:extLst>
+  </p:cSld>
+  <p:clrMapOvr>
+    <a:masterClrMapping/>
+  </p:clrMapOvr>
+</p:sld>
+</file>
+
+<file path=ppt/slides/slide10.xml><?xml version="1.0" encoding="utf-8"?>
+<p:sld xmlns:a="http://schemas.openxmlformats.org/drawingml/2006/main" xmlns:r="http://schemas.openxmlformats.org/officeDocument/2006/relationships" xmlns:p="http://schemas.openxmlformats.org/presentationml/2006/main">
+  <p:cSld>
+    <p:spTree>
+      <p:nvGrpSpPr>
+        <p:cNvPr id="1" name="">
+          <a:extLst>
+            <a:ext uri="{FF2B5EF4-FFF2-40B4-BE49-F238E27FC236}">
+              <a16:creationId xmlns:a16="http://schemas.microsoft.com/office/drawing/2014/main" id="{6DCEE22F-8E76-35F2-10AD-9AA93BE3E5D8}"/>
+            </a:ext>
+          </a:extLst>
+        </p:cNvPr>
+        <p:cNvGrpSpPr/>
+        <p:nvPr/>
+      </p:nvGrpSpPr>
+      <p:grpSpPr>
+        <a:xfrm>
+          <a:off x="0" y="0"/>
+          <a:ext cx="0" cy="0"/>
+          <a:chOff x="0" y="0"/>
+          <a:chExt cx="0" cy="0"/>
+        </a:xfrm>
+      </p:grpSpPr>
+      <p:sp>
+        <p:nvSpPr>
+          <p:cNvPr id="3" name="TextBox 2">
+            <a:extLst>
+              <a:ext uri="{FF2B5EF4-FFF2-40B4-BE49-F238E27FC236}">
+                <a16:creationId xmlns:a16="http://schemas.microsoft.com/office/drawing/2014/main" id="{20FF11A9-9677-FC9C-B541-23BBBC81B2CD}"/>
+              </a:ext>
+            </a:extLst>
+          </p:cNvPr>
+          <p:cNvSpPr txBox="1"/>
+          <p:nvPr/>
+        </p:nvSpPr>
+        <p:spPr>
+          <a:xfrm>
+            <a:off x="217714" y="255046"/>
+            <a:ext cx="11756571" cy="355354"/>
+          </a:xfrm>
+          <a:prstGeom prst="rect">
+            <a:avLst/>
+          </a:prstGeom>
+          <a:noFill/>
+        </p:spPr>
+        <p:txBody>
+          <a:bodyPr wrap="square">
+            <a:spAutoFit/>
+          </a:bodyPr>
+          <a:lstStyle/>
+          <a:p>
+            <a:pPr>
+              <a:lnSpc>
+                <a:spcPct val="150000"/>
+              </a:lnSpc>
+              <a:buNone/>
+            </a:pPr>
+            <a:r>
+              <a:rPr lang="en-US" altLang="en-US" sz="1300">
+                <a:latin typeface="Arial" panose="020B0604020202020204" pitchFamily="34" charset="0"/>
+              </a:rPr>
+              <a:t>resources\views\admin\vendor-profile\index.blade.php</a:t>
+            </a:r>
+            <a:endParaRPr kumimoji="0" lang="en-US" altLang="en-US" sz="1300" b="0" i="0" u="none" strike="noStrike" cap="none" normalizeH="0" baseline="0">
+              <a:ln>
+                <a:noFill/>
+              </a:ln>
+              <a:solidFill>
+                <a:schemeClr val="tx1"/>
+              </a:solidFill>
+              <a:effectLst/>
+              <a:latin typeface="Arial" panose="020B0604020202020204" pitchFamily="34" charset="0"/>
+            </a:endParaRPr>
+          </a:p>
+        </p:txBody>
+      </p:sp>
+      <p:pic>
+        <p:nvPicPr>
+          <p:cNvPr id="4" name="Picture 3">
+            <a:extLst>
+              <a:ext uri="{FF2B5EF4-FFF2-40B4-BE49-F238E27FC236}">
+                <a16:creationId xmlns:a16="http://schemas.microsoft.com/office/drawing/2014/main" id="{275C0601-8361-1B9E-4212-263D377CA81D}"/>
+              </a:ext>
+            </a:extLst>
+          </p:cNvPr>
+          <p:cNvPicPr>
+            <a:picLocks noChangeAspect="1"/>
+          </p:cNvPicPr>
+          <p:nvPr/>
+        </p:nvPicPr>
+        <p:blipFill>
+          <a:blip r:embed="rId2"/>
+          <a:stretch>
+            <a:fillRect/>
+          </a:stretch>
+        </p:blipFill>
+        <p:spPr>
+          <a:xfrm>
+            <a:off x="6280726" y="1162850"/>
+            <a:ext cx="5911273" cy="5695150"/>
+          </a:xfrm>
+          <a:prstGeom prst="rect">
+            <a:avLst/>
+          </a:prstGeom>
+        </p:spPr>
+      </p:pic>
+    </p:spTree>
+    <p:extLst>
+      <p:ext uri="{BB962C8B-B14F-4D97-AF65-F5344CB8AC3E}">
+        <p14:creationId xmlns:p14="http://schemas.microsoft.com/office/powerpoint/2010/main" val="2741324440"/>
+      </p:ext>
+    </p:extLst>
+  </p:cSld>
+  <p:clrMapOvr>
+    <a:masterClrMapping/>
+  </p:clrMapOvr>
+</p:sld>
+</file>
+
+<file path=ppt/slides/slide11.xml><?xml version="1.0" encoding="utf-8"?>
+<p:sld xmlns:a="http://schemas.openxmlformats.org/drawingml/2006/main" xmlns:r="http://schemas.openxmlformats.org/officeDocument/2006/relationships" xmlns:p="http://schemas.openxmlformats.org/presentationml/2006/main">
+  <p:cSld>
+    <p:spTree>
+      <p:nvGrpSpPr>
+        <p:cNvPr id="1" name="">
+          <a:extLst>
+            <a:ext uri="{FF2B5EF4-FFF2-40B4-BE49-F238E27FC236}">
+              <a16:creationId xmlns:a16="http://schemas.microsoft.com/office/drawing/2014/main" id="{D32AC917-E69F-0344-4D66-3724EC916C95}"/>
+            </a:ext>
+          </a:extLst>
+        </p:cNvPr>
+        <p:cNvGrpSpPr/>
+        <p:nvPr/>
+      </p:nvGrpSpPr>
+      <p:grpSpPr>
+        <a:xfrm>
+          <a:off x="0" y="0"/>
+          <a:ext cx="0" cy="0"/>
+          <a:chOff x="0" y="0"/>
+          <a:chExt cx="0" cy="0"/>
+        </a:xfrm>
+      </p:grpSpPr>
+      <p:sp>
+        <p:nvSpPr>
+          <p:cNvPr id="3" name="TextBox 2">
+            <a:extLst>
+              <a:ext uri="{FF2B5EF4-FFF2-40B4-BE49-F238E27FC236}">
+                <a16:creationId xmlns:a16="http://schemas.microsoft.com/office/drawing/2014/main" id="{7A3DEA1A-303F-713F-0150-B146022F9D90}"/>
+              </a:ext>
+            </a:extLst>
+          </p:cNvPr>
+          <p:cNvSpPr txBox="1"/>
+          <p:nvPr/>
+        </p:nvSpPr>
+        <p:spPr>
+          <a:xfrm>
+            <a:off x="217714" y="255046"/>
+            <a:ext cx="11756571" cy="355354"/>
+          </a:xfrm>
+          <a:prstGeom prst="rect">
+            <a:avLst/>
+          </a:prstGeom>
+          <a:noFill/>
+        </p:spPr>
+        <p:txBody>
+          <a:bodyPr wrap="square">
+            <a:spAutoFit/>
+          </a:bodyPr>
+          <a:lstStyle/>
+          <a:p>
+            <a:pPr>
+              <a:lnSpc>
+                <a:spcPct val="150000"/>
+              </a:lnSpc>
+              <a:buNone/>
+            </a:pPr>
+            <a:r>
+              <a:rPr lang="en-US" altLang="en-US" sz="1300">
+                <a:latin typeface="Arial" panose="020B0604020202020204" pitchFamily="34" charset="0"/>
+              </a:rPr>
+              <a:t>resources\views\admin\vendor-profile\index.blade.php</a:t>
+            </a:r>
+            <a:endParaRPr kumimoji="0" lang="en-US" altLang="en-US" sz="1300" b="0" i="0" u="none" strike="noStrike" cap="none" normalizeH="0" baseline="0">
+              <a:ln>
+                <a:noFill/>
+              </a:ln>
+              <a:solidFill>
+                <a:schemeClr val="tx1"/>
+              </a:solidFill>
+              <a:effectLst/>
+              <a:latin typeface="Arial" panose="020B0604020202020204" pitchFamily="34" charset="0"/>
+            </a:endParaRPr>
+          </a:p>
+        </p:txBody>
+      </p:sp>
+      <p:pic>
+        <p:nvPicPr>
+          <p:cNvPr id="6" name="Picture 5">
+            <a:extLst>
+              <a:ext uri="{FF2B5EF4-FFF2-40B4-BE49-F238E27FC236}">
+                <a16:creationId xmlns:a16="http://schemas.microsoft.com/office/drawing/2014/main" id="{02046782-6AF5-8CB8-9EC0-7D953C20A502}"/>
+              </a:ext>
+            </a:extLst>
+          </p:cNvPr>
+          <p:cNvPicPr>
+            <a:picLocks noChangeAspect="1"/>
+          </p:cNvPicPr>
+          <p:nvPr/>
+        </p:nvPicPr>
+        <p:blipFill>
+          <a:blip r:embed="rId2"/>
+          <a:stretch>
+            <a:fillRect/>
+          </a:stretch>
+        </p:blipFill>
+        <p:spPr>
+          <a:xfrm>
+            <a:off x="4887783" y="0"/>
+            <a:ext cx="7304217" cy="6858000"/>
+          </a:xfrm>
+          <a:prstGeom prst="rect">
+            <a:avLst/>
+          </a:prstGeom>
+        </p:spPr>
+      </p:pic>
+    </p:spTree>
+    <p:extLst>
+      <p:ext uri="{BB962C8B-B14F-4D97-AF65-F5344CB8AC3E}">
+        <p14:creationId xmlns:p14="http://schemas.microsoft.com/office/powerpoint/2010/main" val="2265230910"/>
+      </p:ext>
+    </p:extLst>
+  </p:cSld>
+  <p:clrMapOvr>
+    <a:masterClrMapping/>
+  </p:clrMapOvr>
+</p:sld>
+</file>
+
+<file path=ppt/slides/slide12.xml><?xml version="1.0" encoding="utf-8"?>
+<p:sld xmlns:a="http://schemas.openxmlformats.org/drawingml/2006/main" xmlns:r="http://schemas.openxmlformats.org/officeDocument/2006/relationships" xmlns:p="http://schemas.openxmlformats.org/presentationml/2006/main">
+  <p:cSld>
+    <p:spTree>
+      <p:nvGrpSpPr>
+        <p:cNvPr id="1" name="">
+          <a:extLst>
+            <a:ext uri="{FF2B5EF4-FFF2-40B4-BE49-F238E27FC236}">
+              <a16:creationId xmlns:a16="http://schemas.microsoft.com/office/drawing/2014/main" id="{0157F1C0-87DB-1954-6A11-E8E738192791}"/>
+            </a:ext>
+          </a:extLst>
+        </p:cNvPr>
+        <p:cNvGrpSpPr/>
+        <p:nvPr/>
+      </p:nvGrpSpPr>
+      <p:grpSpPr>
+        <a:xfrm>
+          <a:off x="0" y="0"/>
+          <a:ext cx="0" cy="0"/>
+          <a:chOff x="0" y="0"/>
+          <a:chExt cx="0" cy="0"/>
+        </a:xfrm>
+      </p:grpSpPr>
+      <p:sp>
+        <p:nvSpPr>
+          <p:cNvPr id="3" name="TextBox 2">
+            <a:extLst>
+              <a:ext uri="{FF2B5EF4-FFF2-40B4-BE49-F238E27FC236}">
+                <a16:creationId xmlns:a16="http://schemas.microsoft.com/office/drawing/2014/main" id="{5C2A9F89-F126-CF92-EE21-665DD59B39C8}"/>
+              </a:ext>
+            </a:extLst>
+          </p:cNvPr>
+          <p:cNvSpPr txBox="1"/>
+          <p:nvPr/>
+        </p:nvSpPr>
+        <p:spPr>
+          <a:xfrm>
+            <a:off x="217714" y="255046"/>
+            <a:ext cx="11756571" cy="355354"/>
+          </a:xfrm>
+          <a:prstGeom prst="rect">
+            <a:avLst/>
+          </a:prstGeom>
+          <a:noFill/>
+        </p:spPr>
+        <p:txBody>
+          <a:bodyPr wrap="square">
+            <a:spAutoFit/>
+          </a:bodyPr>
+          <a:lstStyle/>
+          <a:p>
+            <a:pPr>
+              <a:lnSpc>
+                <a:spcPct val="150000"/>
+              </a:lnSpc>
+              <a:buNone/>
+            </a:pPr>
+            <a:r>
+              <a:rPr kumimoji="0" lang="az-Latn-AZ" altLang="en-US" sz="1300" b="0" i="0" u="none" strike="noStrike" cap="none" normalizeH="0" baseline="0">
+                <a:ln>
+                  <a:noFill/>
+                </a:ln>
+                <a:solidFill>
+                  <a:schemeClr val="tx1"/>
+                </a:solidFill>
+                <a:effectLst/>
+                <a:latin typeface="Arial" panose="020B0604020202020204" pitchFamily="34" charset="0"/>
+              </a:rPr>
+              <a:t>İlkin nəticə.</a:t>
+            </a:r>
+            <a:endParaRPr kumimoji="0" lang="en-US" altLang="en-US" sz="1300" b="0" i="0" u="none" strike="noStrike" cap="none" normalizeH="0" baseline="0">
+              <a:ln>
+                <a:noFill/>
+              </a:ln>
+              <a:solidFill>
+                <a:schemeClr val="tx1"/>
+              </a:solidFill>
+              <a:effectLst/>
+              <a:latin typeface="Arial" panose="020B0604020202020204" pitchFamily="34" charset="0"/>
+            </a:endParaRPr>
+          </a:p>
+        </p:txBody>
+      </p:sp>
+      <p:pic>
+        <p:nvPicPr>
+          <p:cNvPr id="4" name="Picture 3">
+            <a:extLst>
+              <a:ext uri="{FF2B5EF4-FFF2-40B4-BE49-F238E27FC236}">
+                <a16:creationId xmlns:a16="http://schemas.microsoft.com/office/drawing/2014/main" id="{E60FF7CB-5F20-CFE1-E8BD-C507275DED5D}"/>
+              </a:ext>
+            </a:extLst>
+          </p:cNvPr>
+          <p:cNvPicPr>
+            <a:picLocks noChangeAspect="1"/>
+          </p:cNvPicPr>
+          <p:nvPr/>
+        </p:nvPicPr>
+        <p:blipFill>
+          <a:blip r:embed="rId2"/>
+          <a:stretch>
+            <a:fillRect/>
+          </a:stretch>
+        </p:blipFill>
+        <p:spPr>
+          <a:xfrm>
+            <a:off x="5075603" y="0"/>
+            <a:ext cx="7116397" cy="6858000"/>
+          </a:xfrm>
+          <a:prstGeom prst="rect">
+            <a:avLst/>
+          </a:prstGeom>
+          <a:ln w="38100" cap="sq">
+            <a:solidFill>
+              <a:srgbClr val="000000"/>
+            </a:solidFill>
+            <a:prstDash val="solid"/>
+            <a:miter lim="800000"/>
+          </a:ln>
+          <a:effectLst>
+            <a:outerShdw blurRad="50800" dist="38100" dir="2700000" algn="tl" rotWithShape="0">
+              <a:srgbClr val="000000">
+                <a:alpha val="43000"/>
+              </a:srgbClr>
+            </a:outerShdw>
+          </a:effectLst>
+        </p:spPr>
+      </p:pic>
+    </p:spTree>
+    <p:extLst>
+      <p:ext uri="{BB962C8B-B14F-4D97-AF65-F5344CB8AC3E}">
+        <p14:creationId xmlns:p14="http://schemas.microsoft.com/office/powerpoint/2010/main" val="99660090"/>
+      </p:ext>
+    </p:extLst>
+  </p:cSld>
+  <p:clrMapOvr>
+    <a:masterClrMapping/>
+  </p:clrMapOvr>
+</p:sld>
+</file>
+
+<file path=ppt/slides/slide13.xml><?xml version="1.0" encoding="utf-8"?>
+<p:sld xmlns:a="http://schemas.openxmlformats.org/drawingml/2006/main" xmlns:r="http://schemas.openxmlformats.org/officeDocument/2006/relationships" xmlns:p="http://schemas.openxmlformats.org/presentationml/2006/main">
+  <p:cSld>
+    <p:spTree>
+      <p:nvGrpSpPr>
+        <p:cNvPr id="1" name="">
+          <a:extLst>
+            <a:ext uri="{FF2B5EF4-FFF2-40B4-BE49-F238E27FC236}">
+              <a16:creationId xmlns:a16="http://schemas.microsoft.com/office/drawing/2014/main" id="{7BC865EF-44DC-F52C-9E19-4E697E75B478}"/>
+            </a:ext>
+          </a:extLst>
+        </p:cNvPr>
+        <p:cNvGrpSpPr/>
+        <p:nvPr/>
+      </p:nvGrpSpPr>
+      <p:grpSpPr>
+        <a:xfrm>
+          <a:off x="0" y="0"/>
+          <a:ext cx="0" cy="0"/>
+          <a:chOff x="0" y="0"/>
+          <a:chExt cx="0" cy="0"/>
+        </a:xfrm>
+      </p:grpSpPr>
+      <p:sp>
+        <p:nvSpPr>
+          <p:cNvPr id="3" name="TextBox 2">
+            <a:extLst>
+              <a:ext uri="{FF2B5EF4-FFF2-40B4-BE49-F238E27FC236}">
+                <a16:creationId xmlns:a16="http://schemas.microsoft.com/office/drawing/2014/main" id="{C019482D-1A10-D9A2-EF84-A67A1F46892F}"/>
+              </a:ext>
+            </a:extLst>
+          </p:cNvPr>
+          <p:cNvSpPr txBox="1"/>
+          <p:nvPr/>
+        </p:nvSpPr>
+        <p:spPr>
+          <a:xfrm>
+            <a:off x="217714" y="255046"/>
+            <a:ext cx="11756571" cy="955518"/>
+          </a:xfrm>
+          <a:prstGeom prst="rect">
+            <a:avLst/>
+          </a:prstGeom>
+          <a:noFill/>
+        </p:spPr>
+        <p:txBody>
+          <a:bodyPr wrap="square">
+            <a:spAutoFit/>
+          </a:bodyPr>
+          <a:lstStyle/>
+          <a:p>
+            <a:pPr>
+              <a:lnSpc>
+                <a:spcPct val="150000"/>
+              </a:lnSpc>
+              <a:buNone/>
+            </a:pPr>
+            <a:r>
+              <a:rPr lang="en-US" altLang="en-US" sz="1300">
+                <a:latin typeface="Arial" panose="020B0604020202020204" pitchFamily="34" charset="0"/>
+              </a:rPr>
+              <a:t>app\Http\Controllers\Backend\AdminVendorProfileController.php</a:t>
+            </a:r>
+          </a:p>
+          <a:p>
+            <a:pPr>
+              <a:lnSpc>
+                <a:spcPct val="150000"/>
+              </a:lnSpc>
+              <a:buNone/>
+            </a:pPr>
+            <a:endParaRPr kumimoji="0" lang="en-US" altLang="en-US" sz="1300" b="0" i="0" u="none" strike="noStrike" cap="none" normalizeH="0" baseline="0">
+              <a:ln>
+                <a:noFill/>
+              </a:ln>
+              <a:solidFill>
+                <a:schemeClr val="tx1"/>
+              </a:solidFill>
+              <a:effectLst/>
+              <a:latin typeface="Arial" panose="020B0604020202020204" pitchFamily="34" charset="0"/>
+            </a:endParaRPr>
+          </a:p>
+          <a:p>
+            <a:pPr>
+              <a:lnSpc>
+                <a:spcPct val="150000"/>
+              </a:lnSpc>
+              <a:buNone/>
+            </a:pPr>
+            <a:r>
+              <a:rPr lang="az-Latn-AZ" altLang="en-US" sz="1300">
+                <a:latin typeface="Arial" panose="020B0604020202020204" pitchFamily="34" charset="0"/>
+              </a:rPr>
+              <a:t>Dəyər gəlib gəlmədiyini yoxlamaq üçün şəkildəki kimi yazırıq.</a:t>
+            </a:r>
+            <a:endParaRPr kumimoji="0" lang="en-US" altLang="en-US" sz="1300" b="0" i="0" u="none" strike="noStrike" cap="none" normalizeH="0" baseline="0">
+              <a:ln>
+                <a:noFill/>
+              </a:ln>
+              <a:solidFill>
+                <a:schemeClr val="tx1"/>
+              </a:solidFill>
+              <a:effectLst/>
+              <a:latin typeface="Arial" panose="020B0604020202020204" pitchFamily="34" charset="0"/>
+            </a:endParaRPr>
+          </a:p>
+        </p:txBody>
+      </p:sp>
+      <p:pic>
+        <p:nvPicPr>
+          <p:cNvPr id="4" name="Picture 3">
+            <a:extLst>
+              <a:ext uri="{FF2B5EF4-FFF2-40B4-BE49-F238E27FC236}">
+                <a16:creationId xmlns:a16="http://schemas.microsoft.com/office/drawing/2014/main" id="{31D4C0BD-CBDA-DCED-7679-10E3DA3BE9D2}"/>
+              </a:ext>
+            </a:extLst>
+          </p:cNvPr>
+          <p:cNvPicPr>
+            <a:picLocks noChangeAspect="1"/>
+          </p:cNvPicPr>
+          <p:nvPr/>
+        </p:nvPicPr>
+        <p:blipFill>
+          <a:blip r:embed="rId2"/>
+          <a:stretch>
+            <a:fillRect/>
+          </a:stretch>
+        </p:blipFill>
+        <p:spPr>
+          <a:xfrm>
+            <a:off x="7887511" y="0"/>
+            <a:ext cx="4304489" cy="6858000"/>
+          </a:xfrm>
+          <a:prstGeom prst="rect">
+            <a:avLst/>
+          </a:prstGeom>
+        </p:spPr>
+      </p:pic>
+      <p:pic>
+        <p:nvPicPr>
+          <p:cNvPr id="6" name="Picture 5">
+            <a:extLst>
+              <a:ext uri="{FF2B5EF4-FFF2-40B4-BE49-F238E27FC236}">
+                <a16:creationId xmlns:a16="http://schemas.microsoft.com/office/drawing/2014/main" id="{5337DB40-26AB-D843-B0F9-69D6E8801F88}"/>
+              </a:ext>
+            </a:extLst>
+          </p:cNvPr>
+          <p:cNvPicPr>
+            <a:picLocks noChangeAspect="1"/>
+          </p:cNvPicPr>
+          <p:nvPr/>
+        </p:nvPicPr>
+        <p:blipFill>
+          <a:blip r:embed="rId3"/>
+          <a:srcRect b="11524"/>
+          <a:stretch>
+            <a:fillRect/>
+          </a:stretch>
+        </p:blipFill>
+        <p:spPr>
+          <a:xfrm>
+            <a:off x="0" y="4590726"/>
+            <a:ext cx="5325218" cy="2267274"/>
+          </a:xfrm>
+          <a:prstGeom prst="rect">
+            <a:avLst/>
+          </a:prstGeom>
+        </p:spPr>
+      </p:pic>
+    </p:spTree>
+    <p:extLst>
+      <p:ext uri="{BB962C8B-B14F-4D97-AF65-F5344CB8AC3E}">
+        <p14:creationId xmlns:p14="http://schemas.microsoft.com/office/powerpoint/2010/main" val="213004049"/>
+      </p:ext>
+    </p:extLst>
+  </p:cSld>
+  <p:clrMapOvr>
+    <a:masterClrMapping/>
+  </p:clrMapOvr>
+</p:sld>
+</file>
+
+<file path=ppt/slides/slide14.xml><?xml version="1.0" encoding="utf-8"?>
+<p:sld xmlns:a="http://schemas.openxmlformats.org/drawingml/2006/main" xmlns:r="http://schemas.openxmlformats.org/officeDocument/2006/relationships" xmlns:p="http://schemas.openxmlformats.org/presentationml/2006/main">
+  <p:cSld>
+    <p:spTree>
+      <p:nvGrpSpPr>
+        <p:cNvPr id="1" name="">
+          <a:extLst>
+            <a:ext uri="{FF2B5EF4-FFF2-40B4-BE49-F238E27FC236}">
+              <a16:creationId xmlns:a16="http://schemas.microsoft.com/office/drawing/2014/main" id="{1E1B9E76-7405-E7E1-8B1A-E104FE3CB581}"/>
+            </a:ext>
+          </a:extLst>
+        </p:cNvPr>
+        <p:cNvGrpSpPr/>
+        <p:nvPr/>
+      </p:nvGrpSpPr>
+      <p:grpSpPr>
+        <a:xfrm>
+          <a:off x="0" y="0"/>
+          <a:ext cx="0" cy="0"/>
+          <a:chOff x="0" y="0"/>
+          <a:chExt cx="0" cy="0"/>
+        </a:xfrm>
+      </p:grpSpPr>
+      <p:sp>
+        <p:nvSpPr>
+          <p:cNvPr id="3" name="TextBox 2">
+            <a:extLst>
+              <a:ext uri="{FF2B5EF4-FFF2-40B4-BE49-F238E27FC236}">
+                <a16:creationId xmlns:a16="http://schemas.microsoft.com/office/drawing/2014/main" id="{CB848B07-0956-702A-3D40-3064DD823BA7}"/>
+              </a:ext>
+            </a:extLst>
+          </p:cNvPr>
+          <p:cNvSpPr txBox="1"/>
+          <p:nvPr/>
+        </p:nvSpPr>
+        <p:spPr>
+          <a:xfrm>
+            <a:off x="217714" y="255046"/>
+            <a:ext cx="11756571" cy="355354"/>
+          </a:xfrm>
+          <a:prstGeom prst="rect">
+            <a:avLst/>
+          </a:prstGeom>
+          <a:noFill/>
+        </p:spPr>
+        <p:txBody>
+          <a:bodyPr wrap="square">
+            <a:spAutoFit/>
+          </a:bodyPr>
+          <a:lstStyle/>
+          <a:p>
+            <a:pPr>
+              <a:lnSpc>
+                <a:spcPct val="150000"/>
+              </a:lnSpc>
+              <a:buNone/>
+            </a:pPr>
+            <a:r>
+              <a:rPr lang="az-Latn-AZ" altLang="en-US" sz="1300">
+                <a:latin typeface="Arial" panose="020B0604020202020204" pitchFamily="34" charset="0"/>
+              </a:rPr>
+              <a:t>Cədvələ </a:t>
+            </a:r>
+            <a:r>
+              <a:rPr lang="az-Latn-AZ" altLang="en-US" sz="1300" b="1">
+                <a:latin typeface="Arial" panose="020B0604020202020204" pitchFamily="34" charset="0"/>
+              </a:rPr>
+              <a:t>user_id </a:t>
+            </a:r>
+            <a:r>
+              <a:rPr lang="az-Latn-AZ" altLang="en-US" sz="1300">
+                <a:latin typeface="Arial" panose="020B0604020202020204" pitchFamily="34" charset="0"/>
+              </a:rPr>
+              <a:t>əlavə edirik. </a:t>
+            </a:r>
+            <a:endParaRPr kumimoji="0" lang="en-US" altLang="en-US" sz="1300" b="0" i="0" u="none" strike="noStrike" cap="none" normalizeH="0" baseline="0">
+              <a:ln>
+                <a:noFill/>
+              </a:ln>
+              <a:solidFill>
+                <a:schemeClr val="tx1"/>
+              </a:solidFill>
+              <a:effectLst/>
+              <a:latin typeface="Arial" panose="020B0604020202020204" pitchFamily="34" charset="0"/>
+            </a:endParaRPr>
+          </a:p>
+        </p:txBody>
+      </p:sp>
+      <p:pic>
+        <p:nvPicPr>
+          <p:cNvPr id="4" name="Picture 3">
+            <a:extLst>
+              <a:ext uri="{FF2B5EF4-FFF2-40B4-BE49-F238E27FC236}">
+                <a16:creationId xmlns:a16="http://schemas.microsoft.com/office/drawing/2014/main" id="{70FEE1F5-190E-212C-4F49-1E2F8280E0BB}"/>
+              </a:ext>
+            </a:extLst>
+          </p:cNvPr>
+          <p:cNvPicPr>
+            <a:picLocks noChangeAspect="1"/>
+          </p:cNvPicPr>
+          <p:nvPr/>
+        </p:nvPicPr>
+        <p:blipFill>
+          <a:blip r:embed="rId2"/>
+          <a:stretch>
+            <a:fillRect/>
+          </a:stretch>
+        </p:blipFill>
+        <p:spPr>
+          <a:xfrm>
+            <a:off x="6812096" y="0"/>
+            <a:ext cx="5379904" cy="6858000"/>
+          </a:xfrm>
+          <a:prstGeom prst="rect">
+            <a:avLst/>
+          </a:prstGeom>
+        </p:spPr>
+      </p:pic>
+    </p:spTree>
+    <p:extLst>
+      <p:ext uri="{BB962C8B-B14F-4D97-AF65-F5344CB8AC3E}">
+        <p14:creationId xmlns:p14="http://schemas.microsoft.com/office/powerpoint/2010/main" val="3265801790"/>
+      </p:ext>
+    </p:extLst>
+  </p:cSld>
+  <p:clrMapOvr>
+    <a:masterClrMapping/>
+  </p:clrMapOvr>
+</p:sld>
+</file>
+
+<file path=ppt/slides/slide15.xml><?xml version="1.0" encoding="utf-8"?>
+<p:sld xmlns:a="http://schemas.openxmlformats.org/drawingml/2006/main" xmlns:r="http://schemas.openxmlformats.org/officeDocument/2006/relationships" xmlns:p="http://schemas.openxmlformats.org/presentationml/2006/main">
+  <p:cSld>
+    <p:spTree>
+      <p:nvGrpSpPr>
+        <p:cNvPr id="1" name="">
+          <a:extLst>
+            <a:ext uri="{FF2B5EF4-FFF2-40B4-BE49-F238E27FC236}">
+              <a16:creationId xmlns:a16="http://schemas.microsoft.com/office/drawing/2014/main" id="{ED794419-5235-957F-2679-A481ABE656E1}"/>
+            </a:ext>
+          </a:extLst>
+        </p:cNvPr>
+        <p:cNvGrpSpPr/>
+        <p:nvPr/>
+      </p:nvGrpSpPr>
+      <p:grpSpPr>
+        <a:xfrm>
+          <a:off x="0" y="0"/>
+          <a:ext cx="0" cy="0"/>
+          <a:chOff x="0" y="0"/>
+          <a:chExt cx="0" cy="0"/>
+        </a:xfrm>
+      </p:grpSpPr>
+      <p:sp>
+        <p:nvSpPr>
+          <p:cNvPr id="3" name="TextBox 2">
+            <a:extLst>
+              <a:ext uri="{FF2B5EF4-FFF2-40B4-BE49-F238E27FC236}">
+                <a16:creationId xmlns:a16="http://schemas.microsoft.com/office/drawing/2014/main" id="{496B2A98-59B8-C211-125C-360F6068C3DB}"/>
+              </a:ext>
+            </a:extLst>
+          </p:cNvPr>
+          <p:cNvSpPr txBox="1"/>
+          <p:nvPr/>
+        </p:nvSpPr>
+        <p:spPr>
+          <a:xfrm>
+            <a:off x="217714" y="255046"/>
+            <a:ext cx="11756571" cy="355354"/>
+          </a:xfrm>
+          <a:prstGeom prst="rect">
+            <a:avLst/>
+          </a:prstGeom>
+          <a:noFill/>
+        </p:spPr>
+        <p:txBody>
+          <a:bodyPr wrap="square">
+            <a:spAutoFit/>
+          </a:bodyPr>
+          <a:lstStyle/>
+          <a:p>
+            <a:pPr>
+              <a:lnSpc>
+                <a:spcPct val="150000"/>
+              </a:lnSpc>
+              <a:buNone/>
+            </a:pPr>
+            <a:r>
+              <a:rPr lang="az-Latn-AZ" altLang="en-US" sz="1300">
+                <a:latin typeface="Arial" panose="020B0604020202020204" pitchFamily="34" charset="0"/>
+              </a:rPr>
+              <a:t>Bir addım geriyə rollback edərək yenidən migrate edirik.</a:t>
+            </a:r>
+            <a:endParaRPr kumimoji="0" lang="en-US" altLang="en-US" sz="1300" b="0" i="0" u="none" strike="noStrike" cap="none" normalizeH="0" baseline="0">
+              <a:ln>
+                <a:noFill/>
+              </a:ln>
+              <a:solidFill>
+                <a:schemeClr val="tx1"/>
+              </a:solidFill>
+              <a:effectLst/>
+              <a:latin typeface="Arial" panose="020B0604020202020204" pitchFamily="34" charset="0"/>
+            </a:endParaRPr>
+          </a:p>
+        </p:txBody>
+      </p:sp>
+      <p:pic>
+        <p:nvPicPr>
+          <p:cNvPr id="4" name="Picture 3">
+            <a:extLst>
+              <a:ext uri="{FF2B5EF4-FFF2-40B4-BE49-F238E27FC236}">
+                <a16:creationId xmlns:a16="http://schemas.microsoft.com/office/drawing/2014/main" id="{623646AE-6629-B61F-0458-92BADA5A3F9D}"/>
+              </a:ext>
+            </a:extLst>
+          </p:cNvPr>
+          <p:cNvPicPr>
+            <a:picLocks noChangeAspect="1"/>
+          </p:cNvPicPr>
+          <p:nvPr/>
+        </p:nvPicPr>
+        <p:blipFill>
+          <a:blip r:embed="rId2"/>
+          <a:stretch>
+            <a:fillRect/>
+          </a:stretch>
+        </p:blipFill>
+        <p:spPr>
+          <a:xfrm>
+            <a:off x="1684459" y="3647627"/>
+            <a:ext cx="10507541" cy="3210373"/>
+          </a:xfrm>
+          <a:prstGeom prst="rect">
+            <a:avLst/>
+          </a:prstGeom>
+        </p:spPr>
+      </p:pic>
+    </p:spTree>
+    <p:extLst>
+      <p:ext uri="{BB962C8B-B14F-4D97-AF65-F5344CB8AC3E}">
+        <p14:creationId xmlns:p14="http://schemas.microsoft.com/office/powerpoint/2010/main" val="4231743509"/>
+      </p:ext>
+    </p:extLst>
+  </p:cSld>
+  <p:clrMapOvr>
+    <a:masterClrMapping/>
+  </p:clrMapOvr>
+</p:sld>
+</file>
+
+<file path=ppt/slides/slide16.xml><?xml version="1.0" encoding="utf-8"?>
+<p:sld xmlns:a="http://schemas.openxmlformats.org/drawingml/2006/main" xmlns:r="http://schemas.openxmlformats.org/officeDocument/2006/relationships" xmlns:p="http://schemas.openxmlformats.org/presentationml/2006/main">
+  <p:cSld>
+    <p:spTree>
+      <p:nvGrpSpPr>
+        <p:cNvPr id="1" name="">
+          <a:extLst>
+            <a:ext uri="{FF2B5EF4-FFF2-40B4-BE49-F238E27FC236}">
+              <a16:creationId xmlns:a16="http://schemas.microsoft.com/office/drawing/2014/main" id="{14A9CF0B-1BC4-EC05-8451-D55B98E9F9DE}"/>
+            </a:ext>
+          </a:extLst>
+        </p:cNvPr>
+        <p:cNvGrpSpPr/>
+        <p:nvPr/>
+      </p:nvGrpSpPr>
+      <p:grpSpPr>
+        <a:xfrm>
+          <a:off x="0" y="0"/>
+          <a:ext cx="0" cy="0"/>
+          <a:chOff x="0" y="0"/>
+          <a:chExt cx="0" cy="0"/>
+        </a:xfrm>
+      </p:grpSpPr>
+      <p:sp>
+        <p:nvSpPr>
+          <p:cNvPr id="3" name="TextBox 2">
+            <a:extLst>
+              <a:ext uri="{FF2B5EF4-FFF2-40B4-BE49-F238E27FC236}">
+                <a16:creationId xmlns:a16="http://schemas.microsoft.com/office/drawing/2014/main" id="{07795139-2181-36E3-117B-72B4336B3A90}"/>
+              </a:ext>
+            </a:extLst>
+          </p:cNvPr>
+          <p:cNvSpPr txBox="1"/>
+          <p:nvPr/>
+        </p:nvSpPr>
+        <p:spPr>
+          <a:xfrm>
+            <a:off x="217714" y="255046"/>
+            <a:ext cx="11756571" cy="355354"/>
+          </a:xfrm>
+          <a:prstGeom prst="rect">
+            <a:avLst/>
+          </a:prstGeom>
+          <a:noFill/>
+        </p:spPr>
+        <p:txBody>
+          <a:bodyPr wrap="square">
+            <a:spAutoFit/>
+          </a:bodyPr>
+          <a:lstStyle/>
+          <a:p>
+            <a:pPr>
+              <a:lnSpc>
+                <a:spcPct val="150000"/>
+              </a:lnSpc>
+              <a:buNone/>
+            </a:pPr>
+            <a:r>
+              <a:rPr lang="az-Latn-AZ" altLang="en-US" sz="1300">
+                <a:latin typeface="Arial" panose="020B0604020202020204" pitchFamily="34" charset="0"/>
+              </a:rPr>
+              <a:t>Seeder yaradırıq.</a:t>
+            </a:r>
+            <a:endParaRPr kumimoji="0" lang="en-US" altLang="en-US" sz="1300" b="0" i="0" u="none" strike="noStrike" cap="none" normalizeH="0" baseline="0">
+              <a:ln>
+                <a:noFill/>
+              </a:ln>
+              <a:solidFill>
+                <a:schemeClr val="tx1"/>
+              </a:solidFill>
+              <a:effectLst/>
+              <a:latin typeface="Arial" panose="020B0604020202020204" pitchFamily="34" charset="0"/>
+            </a:endParaRPr>
+          </a:p>
+        </p:txBody>
+      </p:sp>
+      <p:pic>
+        <p:nvPicPr>
+          <p:cNvPr id="4" name="Picture 3">
+            <a:extLst>
+              <a:ext uri="{FF2B5EF4-FFF2-40B4-BE49-F238E27FC236}">
+                <a16:creationId xmlns:a16="http://schemas.microsoft.com/office/drawing/2014/main" id="{9A4383F7-AB49-E9E6-47C5-DD6CEE479E76}"/>
+              </a:ext>
+            </a:extLst>
+          </p:cNvPr>
+          <p:cNvPicPr>
+            <a:picLocks noChangeAspect="1"/>
+          </p:cNvPicPr>
+          <p:nvPr/>
+        </p:nvPicPr>
+        <p:blipFill>
+          <a:blip r:embed="rId2"/>
+          <a:stretch>
+            <a:fillRect/>
+          </a:stretch>
+        </p:blipFill>
+        <p:spPr>
+          <a:xfrm>
+            <a:off x="4256568" y="5333787"/>
+            <a:ext cx="7935432" cy="1524213"/>
+          </a:xfrm>
+          <a:prstGeom prst="rect">
+            <a:avLst/>
+          </a:prstGeom>
+        </p:spPr>
+      </p:pic>
+    </p:spTree>
+    <p:extLst>
+      <p:ext uri="{BB962C8B-B14F-4D97-AF65-F5344CB8AC3E}">
+        <p14:creationId xmlns:p14="http://schemas.microsoft.com/office/powerpoint/2010/main" val="3679129660"/>
+      </p:ext>
+    </p:extLst>
+  </p:cSld>
+  <p:clrMapOvr>
+    <a:masterClrMapping/>
+  </p:clrMapOvr>
+</p:sld>
+</file>
+
+<file path=ppt/slides/slide17.xml><?xml version="1.0" encoding="utf-8"?>
+<p:sld xmlns:a="http://schemas.openxmlformats.org/drawingml/2006/main" xmlns:r="http://schemas.openxmlformats.org/officeDocument/2006/relationships" xmlns:p="http://schemas.openxmlformats.org/presentationml/2006/main">
+  <p:cSld>
+    <p:spTree>
+      <p:nvGrpSpPr>
+        <p:cNvPr id="1" name="">
+          <a:extLst>
+            <a:ext uri="{FF2B5EF4-FFF2-40B4-BE49-F238E27FC236}">
+              <a16:creationId xmlns:a16="http://schemas.microsoft.com/office/drawing/2014/main" id="{304A7406-0D15-BDAA-5E06-E91568963859}"/>
+            </a:ext>
+          </a:extLst>
+        </p:cNvPr>
+        <p:cNvGrpSpPr/>
+        <p:nvPr/>
+      </p:nvGrpSpPr>
+      <p:grpSpPr>
+        <a:xfrm>
+          <a:off x="0" y="0"/>
+          <a:ext cx="0" cy="0"/>
+          <a:chOff x="0" y="0"/>
+          <a:chExt cx="0" cy="0"/>
+        </a:xfrm>
+      </p:grpSpPr>
+      <p:sp>
+        <p:nvSpPr>
+          <p:cNvPr id="3" name="TextBox 2">
+            <a:extLst>
+              <a:ext uri="{FF2B5EF4-FFF2-40B4-BE49-F238E27FC236}">
+                <a16:creationId xmlns:a16="http://schemas.microsoft.com/office/drawing/2014/main" id="{D483E4D1-8223-79D1-2993-0A88F8730BE9}"/>
+              </a:ext>
+            </a:extLst>
+          </p:cNvPr>
+          <p:cNvSpPr txBox="1"/>
+          <p:nvPr/>
+        </p:nvSpPr>
+        <p:spPr>
+          <a:xfrm>
+            <a:off x="217714" y="255046"/>
+            <a:ext cx="11756571" cy="955518"/>
+          </a:xfrm>
+          <a:prstGeom prst="rect">
+            <a:avLst/>
+          </a:prstGeom>
+          <a:noFill/>
+        </p:spPr>
+        <p:txBody>
+          <a:bodyPr wrap="square">
+            <a:spAutoFit/>
+          </a:bodyPr>
+          <a:lstStyle/>
+          <a:p>
+            <a:pPr>
+              <a:lnSpc>
+                <a:spcPct val="150000"/>
+              </a:lnSpc>
+              <a:buNone/>
+            </a:pPr>
+            <a:r>
+              <a:rPr lang="en-US" altLang="en-US" sz="1300">
+                <a:latin typeface="Arial" panose="020B0604020202020204" pitchFamily="34" charset="0"/>
+              </a:rPr>
+              <a:t>database\seeders\AdminProfileSeeder.php</a:t>
+            </a:r>
+            <a:endParaRPr lang="az-Latn-AZ" altLang="en-US" sz="1300">
+              <a:latin typeface="Arial" panose="020B0604020202020204" pitchFamily="34" charset="0"/>
+            </a:endParaRPr>
+          </a:p>
+          <a:p>
+            <a:pPr>
+              <a:lnSpc>
+                <a:spcPct val="150000"/>
+              </a:lnSpc>
+              <a:buNone/>
+            </a:pPr>
+            <a:endParaRPr kumimoji="0" lang="az-Latn-AZ" altLang="en-US" sz="1300" b="0" i="0" u="none" strike="noStrike" cap="none" normalizeH="0" baseline="0">
+              <a:ln>
+                <a:noFill/>
+              </a:ln>
+              <a:solidFill>
+                <a:schemeClr val="tx1"/>
+              </a:solidFill>
+              <a:effectLst/>
+              <a:latin typeface="Arial" panose="020B0604020202020204" pitchFamily="34" charset="0"/>
+            </a:endParaRPr>
+          </a:p>
+          <a:p>
+            <a:pPr>
+              <a:lnSpc>
+                <a:spcPct val="150000"/>
+              </a:lnSpc>
+              <a:buNone/>
+            </a:pPr>
+            <a:r>
+              <a:rPr lang="az-Latn-AZ" altLang="en-US" sz="1300" b="1">
+                <a:latin typeface="Arial" panose="020B0604020202020204" pitchFamily="34" charset="0"/>
+              </a:rPr>
+              <a:t>Uploads</a:t>
+            </a:r>
+            <a:r>
+              <a:rPr lang="az-Latn-AZ" altLang="en-US" sz="1300">
+                <a:latin typeface="Arial" panose="020B0604020202020204" pitchFamily="34" charset="0"/>
+              </a:rPr>
+              <a:t> qovluğuna manual olaraq 1343.jpg adında şəkil əlavə etmək lazımdır.</a:t>
+            </a:r>
+            <a:endParaRPr kumimoji="0" lang="en-US" altLang="en-US" sz="1300" b="0" i="0" u="none" strike="noStrike" cap="none" normalizeH="0" baseline="0">
+              <a:ln>
+                <a:noFill/>
+              </a:ln>
+              <a:solidFill>
+                <a:schemeClr val="tx1"/>
+              </a:solidFill>
+              <a:effectLst/>
+              <a:latin typeface="Arial" panose="020B0604020202020204" pitchFamily="34" charset="0"/>
+            </a:endParaRPr>
+          </a:p>
+        </p:txBody>
+      </p:sp>
+      <p:pic>
+        <p:nvPicPr>
+          <p:cNvPr id="6" name="Picture 5">
+            <a:extLst>
+              <a:ext uri="{FF2B5EF4-FFF2-40B4-BE49-F238E27FC236}">
+                <a16:creationId xmlns:a16="http://schemas.microsoft.com/office/drawing/2014/main" id="{26545C26-08CC-34EC-7533-C75AB1E38AC1}"/>
+              </a:ext>
+            </a:extLst>
+          </p:cNvPr>
+          <p:cNvPicPr>
+            <a:picLocks noChangeAspect="1"/>
+          </p:cNvPicPr>
+          <p:nvPr/>
+        </p:nvPicPr>
+        <p:blipFill>
+          <a:blip r:embed="rId2"/>
+          <a:stretch>
+            <a:fillRect/>
+          </a:stretch>
+        </p:blipFill>
+        <p:spPr>
+          <a:xfrm>
+            <a:off x="6552413" y="1266045"/>
+            <a:ext cx="5639587" cy="5591955"/>
+          </a:xfrm>
+          <a:prstGeom prst="rect">
+            <a:avLst/>
+          </a:prstGeom>
+        </p:spPr>
+      </p:pic>
+    </p:spTree>
+    <p:extLst>
+      <p:ext uri="{BB962C8B-B14F-4D97-AF65-F5344CB8AC3E}">
+        <p14:creationId xmlns:p14="http://schemas.microsoft.com/office/powerpoint/2010/main" val="4003172315"/>
+      </p:ext>
+    </p:extLst>
+  </p:cSld>
+  <p:clrMapOvr>
+    <a:masterClrMapping/>
+  </p:clrMapOvr>
+</p:sld>
+</file>
+
+<file path=ppt/slides/slide18.xml><?xml version="1.0" encoding="utf-8"?>
+<p:sld xmlns:a="http://schemas.openxmlformats.org/drawingml/2006/main" xmlns:r="http://schemas.openxmlformats.org/officeDocument/2006/relationships" xmlns:p="http://schemas.openxmlformats.org/presentationml/2006/main">
+  <p:cSld>
+    <p:spTree>
+      <p:nvGrpSpPr>
+        <p:cNvPr id="1" name="">
+          <a:extLst>
+            <a:ext uri="{FF2B5EF4-FFF2-40B4-BE49-F238E27FC236}">
+              <a16:creationId xmlns:a16="http://schemas.microsoft.com/office/drawing/2014/main" id="{CF8BB850-F710-30BB-5F41-F8C3BFFFD534}"/>
+            </a:ext>
+          </a:extLst>
+        </p:cNvPr>
+        <p:cNvGrpSpPr/>
+        <p:nvPr/>
+      </p:nvGrpSpPr>
+      <p:grpSpPr>
+        <a:xfrm>
+          <a:off x="0" y="0"/>
+          <a:ext cx="0" cy="0"/>
+          <a:chOff x="0" y="0"/>
+          <a:chExt cx="0" cy="0"/>
+        </a:xfrm>
+      </p:grpSpPr>
+      <p:sp>
+        <p:nvSpPr>
+          <p:cNvPr id="3" name="TextBox 2">
+            <a:extLst>
+              <a:ext uri="{FF2B5EF4-FFF2-40B4-BE49-F238E27FC236}">
+                <a16:creationId xmlns:a16="http://schemas.microsoft.com/office/drawing/2014/main" id="{83A4FCF9-C51B-30CC-B325-D7CCF11FEE00}"/>
+              </a:ext>
+            </a:extLst>
+          </p:cNvPr>
+          <p:cNvSpPr txBox="1"/>
+          <p:nvPr/>
+        </p:nvSpPr>
+        <p:spPr>
+          <a:xfrm>
             <a:off x="217714" y="255046"/>
             <a:ext cx="11756571" cy="355354"/>
           </a:xfrm>
@@ -3384,10 +4620,232 @@
           </a:p>
         </p:txBody>
       </p:sp>
+      <p:pic>
+        <p:nvPicPr>
+          <p:cNvPr id="4" name="Picture 3">
+            <a:extLst>
+              <a:ext uri="{FF2B5EF4-FFF2-40B4-BE49-F238E27FC236}">
+                <a16:creationId xmlns:a16="http://schemas.microsoft.com/office/drawing/2014/main" id="{3B0D8EB9-F839-A821-A7CA-138CF1734A32}"/>
+              </a:ext>
+            </a:extLst>
+          </p:cNvPr>
+          <p:cNvPicPr>
+            <a:picLocks noChangeAspect="1"/>
+          </p:cNvPicPr>
+          <p:nvPr/>
+        </p:nvPicPr>
+        <p:blipFill>
+          <a:blip r:embed="rId2"/>
+          <a:stretch>
+            <a:fillRect/>
+          </a:stretch>
+        </p:blipFill>
+        <p:spPr>
+          <a:xfrm>
+            <a:off x="4456010" y="0"/>
+            <a:ext cx="7735990" cy="6858000"/>
+          </a:xfrm>
+          <a:prstGeom prst="rect">
+            <a:avLst/>
+          </a:prstGeom>
+        </p:spPr>
+      </p:pic>
     </p:spTree>
     <p:extLst>
       <p:ext uri="{BB962C8B-B14F-4D97-AF65-F5344CB8AC3E}">
-        <p14:creationId xmlns:p14="http://schemas.microsoft.com/office/powerpoint/2010/main" val="3863838039"/>
+        <p14:creationId xmlns:p14="http://schemas.microsoft.com/office/powerpoint/2010/main" val="2341150055"/>
+      </p:ext>
+    </p:extLst>
+  </p:cSld>
+  <p:clrMapOvr>
+    <a:masterClrMapping/>
+  </p:clrMapOvr>
+</p:sld>
+</file>
+
+<file path=ppt/slides/slide19.xml><?xml version="1.0" encoding="utf-8"?>
+<p:sld xmlns:a="http://schemas.openxmlformats.org/drawingml/2006/main" xmlns:r="http://schemas.openxmlformats.org/officeDocument/2006/relationships" xmlns:p="http://schemas.openxmlformats.org/presentationml/2006/main">
+  <p:cSld>
+    <p:spTree>
+      <p:nvGrpSpPr>
+        <p:cNvPr id="1" name="">
+          <a:extLst>
+            <a:ext uri="{FF2B5EF4-FFF2-40B4-BE49-F238E27FC236}">
+              <a16:creationId xmlns:a16="http://schemas.microsoft.com/office/drawing/2014/main" id="{416777FD-C76F-7C3F-CEE6-AE6517F970DC}"/>
+            </a:ext>
+          </a:extLst>
+        </p:cNvPr>
+        <p:cNvGrpSpPr/>
+        <p:nvPr/>
+      </p:nvGrpSpPr>
+      <p:grpSpPr>
+        <a:xfrm>
+          <a:off x="0" y="0"/>
+          <a:ext cx="0" cy="0"/>
+          <a:chOff x="0" y="0"/>
+          <a:chExt cx="0" cy="0"/>
+        </a:xfrm>
+      </p:grpSpPr>
+      <p:sp>
+        <p:nvSpPr>
+          <p:cNvPr id="3" name="TextBox 2">
+            <a:extLst>
+              <a:ext uri="{FF2B5EF4-FFF2-40B4-BE49-F238E27FC236}">
+                <a16:creationId xmlns:a16="http://schemas.microsoft.com/office/drawing/2014/main" id="{3222B3FF-F6F0-2E1C-23D9-D9D7FC702B68}"/>
+              </a:ext>
+            </a:extLst>
+          </p:cNvPr>
+          <p:cNvSpPr txBox="1"/>
+          <p:nvPr/>
+        </p:nvSpPr>
+        <p:spPr>
+          <a:xfrm>
+            <a:off x="217714" y="255046"/>
+            <a:ext cx="11756571" cy="955518"/>
+          </a:xfrm>
+          <a:prstGeom prst="rect">
+            <a:avLst/>
+          </a:prstGeom>
+          <a:noFill/>
+        </p:spPr>
+        <p:txBody>
+          <a:bodyPr wrap="square">
+            <a:spAutoFit/>
+          </a:bodyPr>
+          <a:lstStyle/>
+          <a:p>
+            <a:pPr>
+              <a:lnSpc>
+                <a:spcPct val="150000"/>
+              </a:lnSpc>
+              <a:buNone/>
+            </a:pPr>
+            <a:r>
+              <a:rPr lang="en-US" altLang="en-US" sz="1300">
+                <a:latin typeface="Arial" panose="020B0604020202020204" pitchFamily="34" charset="0"/>
+              </a:rPr>
+              <a:t>database\seeders\DatabaseSeeder.php</a:t>
+            </a:r>
+            <a:endParaRPr lang="az-Latn-AZ" altLang="en-US" sz="1300">
+              <a:latin typeface="Arial" panose="020B0604020202020204" pitchFamily="34" charset="0"/>
+            </a:endParaRPr>
+          </a:p>
+          <a:p>
+            <a:pPr>
+              <a:lnSpc>
+                <a:spcPct val="150000"/>
+              </a:lnSpc>
+              <a:buNone/>
+            </a:pPr>
+            <a:endParaRPr kumimoji="0" lang="az-Latn-AZ" altLang="en-US" sz="1300" b="0" i="0" u="none" strike="noStrike" cap="none" normalizeH="0" baseline="0">
+              <a:ln>
+                <a:noFill/>
+              </a:ln>
+              <a:solidFill>
+                <a:schemeClr val="tx1"/>
+              </a:solidFill>
+              <a:effectLst/>
+              <a:latin typeface="Arial" panose="020B0604020202020204" pitchFamily="34" charset="0"/>
+            </a:endParaRPr>
+          </a:p>
+          <a:p>
+            <a:pPr>
+              <a:lnSpc>
+                <a:spcPct val="150000"/>
+              </a:lnSpc>
+              <a:buNone/>
+            </a:pPr>
+            <a:r>
+              <a:rPr kumimoji="0" lang="az-Latn-AZ" altLang="en-US" sz="1300" b="1" i="0" u="none" strike="noStrike" cap="none" normalizeH="0" baseline="0">
+                <a:ln>
+                  <a:noFill/>
+                </a:ln>
+                <a:solidFill>
+                  <a:schemeClr val="tx1"/>
+                </a:solidFill>
+                <a:effectLst/>
+                <a:latin typeface="Arial" panose="020B0604020202020204" pitchFamily="34" charset="0"/>
+              </a:rPr>
+              <a:t>UserSeeder</a:t>
+            </a:r>
+            <a:r>
+              <a:rPr kumimoji="0" lang="az-Latn-AZ" altLang="en-US" sz="1300" b="0" i="0" u="none" strike="noStrike" cap="none" normalizeH="0" baseline="0">
+                <a:ln>
+                  <a:noFill/>
+                </a:ln>
+                <a:solidFill>
+                  <a:schemeClr val="tx1"/>
+                </a:solidFill>
+                <a:effectLst/>
+                <a:latin typeface="Arial" panose="020B0604020202020204" pitchFamily="34" charset="0"/>
+              </a:rPr>
+              <a:t> -ı</a:t>
+            </a:r>
+            <a:r>
+              <a:rPr lang="az-Latn-AZ" altLang="en-US" sz="1300">
+                <a:latin typeface="Arial" panose="020B0604020202020204" pitchFamily="34" charset="0"/>
+              </a:rPr>
+              <a:t>, commentə alırıq. </a:t>
+            </a:r>
+            <a:r>
+              <a:rPr lang="az-Latn-AZ" altLang="en-US" sz="1300" b="1">
+                <a:latin typeface="Arial" panose="020B0604020202020204" pitchFamily="34" charset="0"/>
+              </a:rPr>
+              <a:t>AdminProfileSeeder</a:t>
+            </a:r>
+            <a:r>
+              <a:rPr lang="az-Latn-AZ" altLang="en-US" sz="1300">
+                <a:latin typeface="Arial" panose="020B0604020202020204" pitchFamily="34" charset="0"/>
+              </a:rPr>
+              <a:t> -ı isə əlavə edirik.</a:t>
+            </a:r>
+            <a:endParaRPr kumimoji="0" lang="en-US" altLang="en-US" sz="1300" b="0" i="0" u="none" strike="noStrike" cap="none" normalizeH="0" baseline="0">
+              <a:ln>
+                <a:noFill/>
+              </a:ln>
+              <a:solidFill>
+                <a:schemeClr val="tx1"/>
+              </a:solidFill>
+              <a:effectLst/>
+              <a:latin typeface="Arial" panose="020B0604020202020204" pitchFamily="34" charset="0"/>
+            </a:endParaRPr>
+          </a:p>
+        </p:txBody>
+      </p:sp>
+      <p:pic>
+        <p:nvPicPr>
+          <p:cNvPr id="4" name="Picture 3">
+            <a:extLst>
+              <a:ext uri="{FF2B5EF4-FFF2-40B4-BE49-F238E27FC236}">
+                <a16:creationId xmlns:a16="http://schemas.microsoft.com/office/drawing/2014/main" id="{660D60ED-627E-5574-C686-01806032DB5C}"/>
+              </a:ext>
+            </a:extLst>
+          </p:cNvPr>
+          <p:cNvPicPr>
+            <a:picLocks noChangeAspect="1"/>
+          </p:cNvPicPr>
+          <p:nvPr/>
+        </p:nvPicPr>
+        <p:blipFill>
+          <a:blip r:embed="rId2"/>
+          <a:stretch>
+            <a:fillRect/>
+          </a:stretch>
+        </p:blipFill>
+        <p:spPr>
+          <a:xfrm>
+            <a:off x="7762257" y="3599995"/>
+            <a:ext cx="4429743" cy="3258005"/>
+          </a:xfrm>
+          <a:prstGeom prst="rect">
+            <a:avLst/>
+          </a:prstGeom>
+        </p:spPr>
+      </p:pic>
+    </p:spTree>
+    <p:extLst>
+      <p:ext uri="{BB962C8B-B14F-4D97-AF65-F5344CB8AC3E}">
+        <p14:creationId xmlns:p14="http://schemas.microsoft.com/office/powerpoint/2010/main" val="923272233"/>
       </p:ext>
     </p:extLst>
   </p:cSld>
@@ -3434,6 +4892,124 @@
         </p:nvSpPr>
         <p:spPr>
           <a:xfrm>
+            <a:off x="217714" y="107264"/>
+            <a:ext cx="11756571" cy="355354"/>
+          </a:xfrm>
+          <a:prstGeom prst="rect">
+            <a:avLst/>
+          </a:prstGeom>
+          <a:noFill/>
+        </p:spPr>
+        <p:txBody>
+          <a:bodyPr wrap="square">
+            <a:spAutoFit/>
+          </a:bodyPr>
+          <a:lstStyle/>
+          <a:p>
+            <a:pPr>
+              <a:lnSpc>
+                <a:spcPct val="150000"/>
+              </a:lnSpc>
+              <a:buNone/>
+            </a:pPr>
+            <a:r>
+              <a:rPr lang="en-US" altLang="en-US" sz="1300">
+                <a:latin typeface="Arial" panose="020B0604020202020204" pitchFamily="34" charset="0"/>
+              </a:rPr>
+              <a:t>Vendor s</a:t>
+            </a:r>
+            <a:r>
+              <a:rPr lang="az-Latn-AZ" altLang="en-US" sz="1300">
+                <a:latin typeface="Arial" panose="020B0604020202020204" pitchFamily="34" charset="0"/>
+              </a:rPr>
+              <a:t>əhifəsini yığacağıq bu dərs.</a:t>
+            </a:r>
+            <a:endParaRPr lang="en-US" altLang="en-US" sz="1300">
+              <a:latin typeface="Arial" panose="020B0604020202020204" pitchFamily="34" charset="0"/>
+            </a:endParaRPr>
+          </a:p>
+        </p:txBody>
+      </p:sp>
+      <p:pic>
+        <p:nvPicPr>
+          <p:cNvPr id="4" name="Picture 3">
+            <a:extLst>
+              <a:ext uri="{FF2B5EF4-FFF2-40B4-BE49-F238E27FC236}">
+                <a16:creationId xmlns:a16="http://schemas.microsoft.com/office/drawing/2014/main" id="{2CA74D56-EF0D-0466-CAE6-392619F23790}"/>
+              </a:ext>
+            </a:extLst>
+          </p:cNvPr>
+          <p:cNvPicPr>
+            <a:picLocks noChangeAspect="1"/>
+          </p:cNvPicPr>
+          <p:nvPr/>
+        </p:nvPicPr>
+        <p:blipFill>
+          <a:blip r:embed="rId2"/>
+          <a:stretch>
+            <a:fillRect/>
+          </a:stretch>
+        </p:blipFill>
+        <p:spPr>
+          <a:xfrm>
+            <a:off x="0" y="536222"/>
+            <a:ext cx="12192000" cy="6321778"/>
+          </a:xfrm>
+          <a:prstGeom prst="rect">
+            <a:avLst/>
+          </a:prstGeom>
+        </p:spPr>
+      </p:pic>
+    </p:spTree>
+    <p:extLst>
+      <p:ext uri="{BB962C8B-B14F-4D97-AF65-F5344CB8AC3E}">
+        <p14:creationId xmlns:p14="http://schemas.microsoft.com/office/powerpoint/2010/main" val="4233252692"/>
+      </p:ext>
+    </p:extLst>
+  </p:cSld>
+  <p:clrMapOvr>
+    <a:masterClrMapping/>
+  </p:clrMapOvr>
+</p:sld>
+</file>
+
+<file path=ppt/slides/slide20.xml><?xml version="1.0" encoding="utf-8"?>
+<p:sld xmlns:a="http://schemas.openxmlformats.org/drawingml/2006/main" xmlns:r="http://schemas.openxmlformats.org/officeDocument/2006/relationships" xmlns:p="http://schemas.openxmlformats.org/presentationml/2006/main">
+  <p:cSld>
+    <p:spTree>
+      <p:nvGrpSpPr>
+        <p:cNvPr id="1" name="">
+          <a:extLst>
+            <a:ext uri="{FF2B5EF4-FFF2-40B4-BE49-F238E27FC236}">
+              <a16:creationId xmlns:a16="http://schemas.microsoft.com/office/drawing/2014/main" id="{531BC677-6386-F02E-B8D8-9BECE23AF1CA}"/>
+            </a:ext>
+          </a:extLst>
+        </p:cNvPr>
+        <p:cNvGrpSpPr/>
+        <p:nvPr/>
+      </p:nvGrpSpPr>
+      <p:grpSpPr>
+        <a:xfrm>
+          <a:off x="0" y="0"/>
+          <a:ext cx="0" cy="0"/>
+          <a:chOff x="0" y="0"/>
+          <a:chExt cx="0" cy="0"/>
+        </a:xfrm>
+      </p:grpSpPr>
+      <p:sp>
+        <p:nvSpPr>
+          <p:cNvPr id="3" name="TextBox 2">
+            <a:extLst>
+              <a:ext uri="{FF2B5EF4-FFF2-40B4-BE49-F238E27FC236}">
+                <a16:creationId xmlns:a16="http://schemas.microsoft.com/office/drawing/2014/main" id="{A7449FDB-75F4-022D-7758-C2323982996B}"/>
+              </a:ext>
+            </a:extLst>
+          </p:cNvPr>
+          <p:cNvSpPr txBox="1"/>
+          <p:nvPr/>
+        </p:nvSpPr>
+        <p:spPr>
+          <a:xfrm>
             <a:off x="217714" y="255046"/>
             <a:ext cx="11756571" cy="355354"/>
           </a:xfrm>
@@ -3470,10 +5046,514 @@
           </a:p>
         </p:txBody>
       </p:sp>
+      <p:pic>
+        <p:nvPicPr>
+          <p:cNvPr id="4" name="Picture 3">
+            <a:extLst>
+              <a:ext uri="{FF2B5EF4-FFF2-40B4-BE49-F238E27FC236}">
+                <a16:creationId xmlns:a16="http://schemas.microsoft.com/office/drawing/2014/main" id="{AB09F520-D9BD-3E47-0794-CC0E9E4033B9}"/>
+              </a:ext>
+            </a:extLst>
+          </p:cNvPr>
+          <p:cNvPicPr>
+            <a:picLocks noChangeAspect="1"/>
+          </p:cNvPicPr>
+          <p:nvPr/>
+        </p:nvPicPr>
+        <p:blipFill>
+          <a:blip r:embed="rId2"/>
+          <a:stretch>
+            <a:fillRect/>
+          </a:stretch>
+        </p:blipFill>
+        <p:spPr>
+          <a:xfrm>
+            <a:off x="1846406" y="4695523"/>
+            <a:ext cx="10345594" cy="2162477"/>
+          </a:xfrm>
+          <a:prstGeom prst="rect">
+            <a:avLst/>
+          </a:prstGeom>
+        </p:spPr>
+      </p:pic>
     </p:spTree>
     <p:extLst>
       <p:ext uri="{BB962C8B-B14F-4D97-AF65-F5344CB8AC3E}">
-        <p14:creationId xmlns:p14="http://schemas.microsoft.com/office/powerpoint/2010/main" val="4233252692"/>
+        <p14:creationId xmlns:p14="http://schemas.microsoft.com/office/powerpoint/2010/main" val="4264412925"/>
+      </p:ext>
+    </p:extLst>
+  </p:cSld>
+  <p:clrMapOvr>
+    <a:masterClrMapping/>
+  </p:clrMapOvr>
+</p:sld>
+</file>
+
+<file path=ppt/slides/slide21.xml><?xml version="1.0" encoding="utf-8"?>
+<p:sld xmlns:a="http://schemas.openxmlformats.org/drawingml/2006/main" xmlns:r="http://schemas.openxmlformats.org/officeDocument/2006/relationships" xmlns:p="http://schemas.openxmlformats.org/presentationml/2006/main">
+  <p:cSld>
+    <p:spTree>
+      <p:nvGrpSpPr>
+        <p:cNvPr id="1" name="">
+          <a:extLst>
+            <a:ext uri="{FF2B5EF4-FFF2-40B4-BE49-F238E27FC236}">
+              <a16:creationId xmlns:a16="http://schemas.microsoft.com/office/drawing/2014/main" id="{E759B041-83E0-DEB9-CEE6-C1A6DDCC9269}"/>
+            </a:ext>
+          </a:extLst>
+        </p:cNvPr>
+        <p:cNvGrpSpPr/>
+        <p:nvPr/>
+      </p:nvGrpSpPr>
+      <p:grpSpPr>
+        <a:xfrm>
+          <a:off x="0" y="0"/>
+          <a:ext cx="0" cy="0"/>
+          <a:chOff x="0" y="0"/>
+          <a:chExt cx="0" cy="0"/>
+        </a:xfrm>
+      </p:grpSpPr>
+      <p:sp>
+        <p:nvSpPr>
+          <p:cNvPr id="3" name="TextBox 2">
+            <a:extLst>
+              <a:ext uri="{FF2B5EF4-FFF2-40B4-BE49-F238E27FC236}">
+                <a16:creationId xmlns:a16="http://schemas.microsoft.com/office/drawing/2014/main" id="{FA3B0136-CBD7-C553-255F-78FF631378AE}"/>
+              </a:ext>
+            </a:extLst>
+          </p:cNvPr>
+          <p:cNvSpPr txBox="1"/>
+          <p:nvPr/>
+        </p:nvSpPr>
+        <p:spPr>
+          <a:xfrm>
+            <a:off x="217714" y="255046"/>
+            <a:ext cx="11756571" cy="355354"/>
+          </a:xfrm>
+          <a:prstGeom prst="rect">
+            <a:avLst/>
+          </a:prstGeom>
+          <a:noFill/>
+        </p:spPr>
+        <p:txBody>
+          <a:bodyPr wrap="square">
+            <a:spAutoFit/>
+          </a:bodyPr>
+          <a:lstStyle/>
+          <a:p>
+            <a:pPr>
+              <a:lnSpc>
+                <a:spcPct val="150000"/>
+              </a:lnSpc>
+              <a:buNone/>
+            </a:pPr>
+            <a:r>
+              <a:rPr kumimoji="0" lang="en-US" altLang="en-US" sz="1300" b="0" i="0" u="none" strike="noStrike" cap="none" normalizeH="0" baseline="0">
+                <a:ln>
+                  <a:noFill/>
+                </a:ln>
+                <a:solidFill>
+                  <a:schemeClr val="tx1"/>
+                </a:solidFill>
+                <a:effectLst/>
+                <a:latin typeface="Arial" panose="020B0604020202020204" pitchFamily="34" charset="0"/>
+              </a:rPr>
+              <a:t>.</a:t>
+            </a:r>
+          </a:p>
+        </p:txBody>
+      </p:sp>
+      <p:pic>
+        <p:nvPicPr>
+          <p:cNvPr id="4" name="Picture 3">
+            <a:extLst>
+              <a:ext uri="{FF2B5EF4-FFF2-40B4-BE49-F238E27FC236}">
+                <a16:creationId xmlns:a16="http://schemas.microsoft.com/office/drawing/2014/main" id="{9E09222B-40F1-1A92-DBA6-479696FEA236}"/>
+              </a:ext>
+            </a:extLst>
+          </p:cNvPr>
+          <p:cNvPicPr>
+            <a:picLocks noChangeAspect="1"/>
+          </p:cNvPicPr>
+          <p:nvPr/>
+        </p:nvPicPr>
+        <p:blipFill>
+          <a:blip r:embed="rId2"/>
+          <a:stretch>
+            <a:fillRect/>
+          </a:stretch>
+        </p:blipFill>
+        <p:spPr>
+          <a:xfrm>
+            <a:off x="0" y="3179874"/>
+            <a:ext cx="12192000" cy="3678126"/>
+          </a:xfrm>
+          <a:prstGeom prst="rect">
+            <a:avLst/>
+          </a:prstGeom>
+          <a:ln w="38100" cap="sq">
+            <a:solidFill>
+              <a:srgbClr val="000000"/>
+            </a:solidFill>
+            <a:prstDash val="solid"/>
+            <a:miter lim="800000"/>
+          </a:ln>
+          <a:effectLst>
+            <a:outerShdw blurRad="50800" dist="38100" dir="2700000" algn="tl" rotWithShape="0">
+              <a:srgbClr val="000000">
+                <a:alpha val="43000"/>
+              </a:srgbClr>
+            </a:outerShdw>
+          </a:effectLst>
+        </p:spPr>
+      </p:pic>
+    </p:spTree>
+    <p:extLst>
+      <p:ext uri="{BB962C8B-B14F-4D97-AF65-F5344CB8AC3E}">
+        <p14:creationId xmlns:p14="http://schemas.microsoft.com/office/powerpoint/2010/main" val="1482567242"/>
+      </p:ext>
+    </p:extLst>
+  </p:cSld>
+  <p:clrMapOvr>
+    <a:masterClrMapping/>
+  </p:clrMapOvr>
+</p:sld>
+</file>
+
+<file path=ppt/slides/slide22.xml><?xml version="1.0" encoding="utf-8"?>
+<p:sld xmlns:a="http://schemas.openxmlformats.org/drawingml/2006/main" xmlns:r="http://schemas.openxmlformats.org/officeDocument/2006/relationships" xmlns:p="http://schemas.openxmlformats.org/presentationml/2006/main">
+  <p:cSld>
+    <p:spTree>
+      <p:nvGrpSpPr>
+        <p:cNvPr id="1" name="">
+          <a:extLst>
+            <a:ext uri="{FF2B5EF4-FFF2-40B4-BE49-F238E27FC236}">
+              <a16:creationId xmlns:a16="http://schemas.microsoft.com/office/drawing/2014/main" id="{DDE73CE0-54A3-5403-7EDF-2FC4728A929A}"/>
+            </a:ext>
+          </a:extLst>
+        </p:cNvPr>
+        <p:cNvGrpSpPr/>
+        <p:nvPr/>
+      </p:nvGrpSpPr>
+      <p:grpSpPr>
+        <a:xfrm>
+          <a:off x="0" y="0"/>
+          <a:ext cx="0" cy="0"/>
+          <a:chOff x="0" y="0"/>
+          <a:chExt cx="0" cy="0"/>
+        </a:xfrm>
+      </p:grpSpPr>
+      <p:sp>
+        <p:nvSpPr>
+          <p:cNvPr id="3" name="TextBox 2">
+            <a:extLst>
+              <a:ext uri="{FF2B5EF4-FFF2-40B4-BE49-F238E27FC236}">
+                <a16:creationId xmlns:a16="http://schemas.microsoft.com/office/drawing/2014/main" id="{6572CEAA-5859-1122-7628-C8599235A6DA}"/>
+              </a:ext>
+            </a:extLst>
+          </p:cNvPr>
+          <p:cNvSpPr txBox="1"/>
+          <p:nvPr/>
+        </p:nvSpPr>
+        <p:spPr>
+          <a:xfrm>
+            <a:off x="217714" y="255046"/>
+            <a:ext cx="11756571" cy="355354"/>
+          </a:xfrm>
+          <a:prstGeom prst="rect">
+            <a:avLst/>
+          </a:prstGeom>
+          <a:noFill/>
+        </p:spPr>
+        <p:txBody>
+          <a:bodyPr wrap="square">
+            <a:spAutoFit/>
+          </a:bodyPr>
+          <a:lstStyle/>
+          <a:p>
+            <a:pPr>
+              <a:lnSpc>
+                <a:spcPct val="150000"/>
+              </a:lnSpc>
+              <a:buNone/>
+            </a:pPr>
+            <a:r>
+              <a:rPr kumimoji="0" lang="en-US" altLang="en-US" sz="1300" b="0" i="0" u="none" strike="noStrike" cap="none" normalizeH="0" baseline="0">
+                <a:ln>
+                  <a:noFill/>
+                </a:ln>
+                <a:solidFill>
+                  <a:schemeClr val="tx1"/>
+                </a:solidFill>
+                <a:effectLst/>
+                <a:latin typeface="Arial" panose="020B0604020202020204" pitchFamily="34" charset="0"/>
+              </a:rPr>
+              <a:t>.</a:t>
+            </a:r>
+          </a:p>
+        </p:txBody>
+      </p:sp>
+    </p:spTree>
+    <p:extLst>
+      <p:ext uri="{BB962C8B-B14F-4D97-AF65-F5344CB8AC3E}">
+        <p14:creationId xmlns:p14="http://schemas.microsoft.com/office/powerpoint/2010/main" val="2006873047"/>
+      </p:ext>
+    </p:extLst>
+  </p:cSld>
+  <p:clrMapOvr>
+    <a:masterClrMapping/>
+  </p:clrMapOvr>
+</p:sld>
+</file>
+
+<file path=ppt/slides/slide23.xml><?xml version="1.0" encoding="utf-8"?>
+<p:sld xmlns:a="http://schemas.openxmlformats.org/drawingml/2006/main" xmlns:r="http://schemas.openxmlformats.org/officeDocument/2006/relationships" xmlns:p="http://schemas.openxmlformats.org/presentationml/2006/main">
+  <p:cSld>
+    <p:spTree>
+      <p:nvGrpSpPr>
+        <p:cNvPr id="1" name="">
+          <a:extLst>
+            <a:ext uri="{FF2B5EF4-FFF2-40B4-BE49-F238E27FC236}">
+              <a16:creationId xmlns:a16="http://schemas.microsoft.com/office/drawing/2014/main" id="{44675AE5-9EA6-23F4-D1B9-7AE220271F3F}"/>
+            </a:ext>
+          </a:extLst>
+        </p:cNvPr>
+        <p:cNvGrpSpPr/>
+        <p:nvPr/>
+      </p:nvGrpSpPr>
+      <p:grpSpPr>
+        <a:xfrm>
+          <a:off x="0" y="0"/>
+          <a:ext cx="0" cy="0"/>
+          <a:chOff x="0" y="0"/>
+          <a:chExt cx="0" cy="0"/>
+        </a:xfrm>
+      </p:grpSpPr>
+      <p:sp>
+        <p:nvSpPr>
+          <p:cNvPr id="3" name="TextBox 2">
+            <a:extLst>
+              <a:ext uri="{FF2B5EF4-FFF2-40B4-BE49-F238E27FC236}">
+                <a16:creationId xmlns:a16="http://schemas.microsoft.com/office/drawing/2014/main" id="{29869AF3-9B06-DCCA-81B4-C5509E693753}"/>
+              </a:ext>
+            </a:extLst>
+          </p:cNvPr>
+          <p:cNvSpPr txBox="1"/>
+          <p:nvPr/>
+        </p:nvSpPr>
+        <p:spPr>
+          <a:xfrm>
+            <a:off x="217714" y="255046"/>
+            <a:ext cx="11756571" cy="355354"/>
+          </a:xfrm>
+          <a:prstGeom prst="rect">
+            <a:avLst/>
+          </a:prstGeom>
+          <a:noFill/>
+        </p:spPr>
+        <p:txBody>
+          <a:bodyPr wrap="square">
+            <a:spAutoFit/>
+          </a:bodyPr>
+          <a:lstStyle/>
+          <a:p>
+            <a:pPr>
+              <a:lnSpc>
+                <a:spcPct val="150000"/>
+              </a:lnSpc>
+              <a:buNone/>
+            </a:pPr>
+            <a:r>
+              <a:rPr kumimoji="0" lang="en-US" altLang="en-US" sz="1300" b="0" i="0" u="none" strike="noStrike" cap="none" normalizeH="0" baseline="0">
+                <a:ln>
+                  <a:noFill/>
+                </a:ln>
+                <a:solidFill>
+                  <a:schemeClr val="tx1"/>
+                </a:solidFill>
+                <a:effectLst/>
+                <a:latin typeface="Arial" panose="020B0604020202020204" pitchFamily="34" charset="0"/>
+              </a:rPr>
+              <a:t>.</a:t>
+            </a:r>
+          </a:p>
+        </p:txBody>
+      </p:sp>
+    </p:spTree>
+    <p:extLst>
+      <p:ext uri="{BB962C8B-B14F-4D97-AF65-F5344CB8AC3E}">
+        <p14:creationId xmlns:p14="http://schemas.microsoft.com/office/powerpoint/2010/main" val="1325142081"/>
+      </p:ext>
+    </p:extLst>
+  </p:cSld>
+  <p:clrMapOvr>
+    <a:masterClrMapping/>
+  </p:clrMapOvr>
+</p:sld>
+</file>
+
+<file path=ppt/slides/slide24.xml><?xml version="1.0" encoding="utf-8"?>
+<p:sld xmlns:a="http://schemas.openxmlformats.org/drawingml/2006/main" xmlns:r="http://schemas.openxmlformats.org/officeDocument/2006/relationships" xmlns:p="http://schemas.openxmlformats.org/presentationml/2006/main">
+  <p:cSld>
+    <p:spTree>
+      <p:nvGrpSpPr>
+        <p:cNvPr id="1" name="">
+          <a:extLst>
+            <a:ext uri="{FF2B5EF4-FFF2-40B4-BE49-F238E27FC236}">
+              <a16:creationId xmlns:a16="http://schemas.microsoft.com/office/drawing/2014/main" id="{71FD34C7-7A75-362E-51CE-93311A026A26}"/>
+            </a:ext>
+          </a:extLst>
+        </p:cNvPr>
+        <p:cNvGrpSpPr/>
+        <p:nvPr/>
+      </p:nvGrpSpPr>
+      <p:grpSpPr>
+        <a:xfrm>
+          <a:off x="0" y="0"/>
+          <a:ext cx="0" cy="0"/>
+          <a:chOff x="0" y="0"/>
+          <a:chExt cx="0" cy="0"/>
+        </a:xfrm>
+      </p:grpSpPr>
+      <p:sp>
+        <p:nvSpPr>
+          <p:cNvPr id="3" name="TextBox 2">
+            <a:extLst>
+              <a:ext uri="{FF2B5EF4-FFF2-40B4-BE49-F238E27FC236}">
+                <a16:creationId xmlns:a16="http://schemas.microsoft.com/office/drawing/2014/main" id="{4C8E8E98-E37A-9FA5-EC1D-B292C3255815}"/>
+              </a:ext>
+            </a:extLst>
+          </p:cNvPr>
+          <p:cNvSpPr txBox="1"/>
+          <p:nvPr/>
+        </p:nvSpPr>
+        <p:spPr>
+          <a:xfrm>
+            <a:off x="217714" y="255046"/>
+            <a:ext cx="11756571" cy="355354"/>
+          </a:xfrm>
+          <a:prstGeom prst="rect">
+            <a:avLst/>
+          </a:prstGeom>
+          <a:noFill/>
+        </p:spPr>
+        <p:txBody>
+          <a:bodyPr wrap="square">
+            <a:spAutoFit/>
+          </a:bodyPr>
+          <a:lstStyle/>
+          <a:p>
+            <a:pPr>
+              <a:lnSpc>
+                <a:spcPct val="150000"/>
+              </a:lnSpc>
+              <a:buNone/>
+            </a:pPr>
+            <a:r>
+              <a:rPr kumimoji="0" lang="en-US" altLang="en-US" sz="1300" b="0" i="0" u="none" strike="noStrike" cap="none" normalizeH="0" baseline="0">
+                <a:ln>
+                  <a:noFill/>
+                </a:ln>
+                <a:solidFill>
+                  <a:schemeClr val="tx1"/>
+                </a:solidFill>
+                <a:effectLst/>
+                <a:latin typeface="Arial" panose="020B0604020202020204" pitchFamily="34" charset="0"/>
+              </a:rPr>
+              <a:t>.</a:t>
+            </a:r>
+          </a:p>
+        </p:txBody>
+      </p:sp>
+    </p:spTree>
+    <p:extLst>
+      <p:ext uri="{BB962C8B-B14F-4D97-AF65-F5344CB8AC3E}">
+        <p14:creationId xmlns:p14="http://schemas.microsoft.com/office/powerpoint/2010/main" val="296869348"/>
+      </p:ext>
+    </p:extLst>
+  </p:cSld>
+  <p:clrMapOvr>
+    <a:masterClrMapping/>
+  </p:clrMapOvr>
+</p:sld>
+</file>
+
+<file path=ppt/slides/slide25.xml><?xml version="1.0" encoding="utf-8"?>
+<p:sld xmlns:a="http://schemas.openxmlformats.org/drawingml/2006/main" xmlns:r="http://schemas.openxmlformats.org/officeDocument/2006/relationships" xmlns:p="http://schemas.openxmlformats.org/presentationml/2006/main">
+  <p:cSld>
+    <p:spTree>
+      <p:nvGrpSpPr>
+        <p:cNvPr id="1" name="">
+          <a:extLst>
+            <a:ext uri="{FF2B5EF4-FFF2-40B4-BE49-F238E27FC236}">
+              <a16:creationId xmlns:a16="http://schemas.microsoft.com/office/drawing/2014/main" id="{3A71044D-BE97-30BC-0C82-4CBFB5AA9003}"/>
+            </a:ext>
+          </a:extLst>
+        </p:cNvPr>
+        <p:cNvGrpSpPr/>
+        <p:nvPr/>
+      </p:nvGrpSpPr>
+      <p:grpSpPr>
+        <a:xfrm>
+          <a:off x="0" y="0"/>
+          <a:ext cx="0" cy="0"/>
+          <a:chOff x="0" y="0"/>
+          <a:chExt cx="0" cy="0"/>
+        </a:xfrm>
+      </p:grpSpPr>
+      <p:sp>
+        <p:nvSpPr>
+          <p:cNvPr id="3" name="TextBox 2">
+            <a:extLst>
+              <a:ext uri="{FF2B5EF4-FFF2-40B4-BE49-F238E27FC236}">
+                <a16:creationId xmlns:a16="http://schemas.microsoft.com/office/drawing/2014/main" id="{2C3722E3-64A5-5204-158E-D4DA7FBBE424}"/>
+              </a:ext>
+            </a:extLst>
+          </p:cNvPr>
+          <p:cNvSpPr txBox="1"/>
+          <p:nvPr/>
+        </p:nvSpPr>
+        <p:spPr>
+          <a:xfrm>
+            <a:off x="217714" y="255046"/>
+            <a:ext cx="11756571" cy="355354"/>
+          </a:xfrm>
+          <a:prstGeom prst="rect">
+            <a:avLst/>
+          </a:prstGeom>
+          <a:noFill/>
+        </p:spPr>
+        <p:txBody>
+          <a:bodyPr wrap="square">
+            <a:spAutoFit/>
+          </a:bodyPr>
+          <a:lstStyle/>
+          <a:p>
+            <a:pPr>
+              <a:lnSpc>
+                <a:spcPct val="150000"/>
+              </a:lnSpc>
+              <a:buNone/>
+            </a:pPr>
+            <a:r>
+              <a:rPr kumimoji="0" lang="en-US" altLang="en-US" sz="1300" b="0" i="0" u="none" strike="noStrike" cap="none" normalizeH="0" baseline="0">
+                <a:ln>
+                  <a:noFill/>
+                </a:ln>
+                <a:solidFill>
+                  <a:schemeClr val="tx1"/>
+                </a:solidFill>
+                <a:effectLst/>
+                <a:latin typeface="Arial" panose="020B0604020202020204" pitchFamily="34" charset="0"/>
+              </a:rPr>
+              <a:t>.</a:t>
+            </a:r>
+          </a:p>
+        </p:txBody>
+      </p:sp>
+    </p:spTree>
+    <p:extLst>
+      <p:ext uri="{BB962C8B-B14F-4D97-AF65-F5344CB8AC3E}">
+        <p14:creationId xmlns:p14="http://schemas.microsoft.com/office/powerpoint/2010/main" val="2418841064"/>
       </p:ext>
     </p:extLst>
   </p:cSld>
@@ -3556,10 +5636,832 @@
           </a:p>
         </p:txBody>
       </p:sp>
+      <p:pic>
+        <p:nvPicPr>
+          <p:cNvPr id="4" name="Picture 3">
+            <a:extLst>
+              <a:ext uri="{FF2B5EF4-FFF2-40B4-BE49-F238E27FC236}">
+                <a16:creationId xmlns:a16="http://schemas.microsoft.com/office/drawing/2014/main" id="{4ADC6336-5031-AC18-537D-83A06FD34FB3}"/>
+              </a:ext>
+            </a:extLst>
+          </p:cNvPr>
+          <p:cNvPicPr>
+            <a:picLocks noChangeAspect="1"/>
+          </p:cNvPicPr>
+          <p:nvPr/>
+        </p:nvPicPr>
+        <p:blipFill>
+          <a:blip r:embed="rId2"/>
+          <a:stretch>
+            <a:fillRect/>
+          </a:stretch>
+        </p:blipFill>
+        <p:spPr>
+          <a:xfrm>
+            <a:off x="1379616" y="4828892"/>
+            <a:ext cx="10812384" cy="2029108"/>
+          </a:xfrm>
+          <a:prstGeom prst="rect">
+            <a:avLst/>
+          </a:prstGeom>
+        </p:spPr>
+      </p:pic>
     </p:spTree>
     <p:extLst>
       <p:ext uri="{BB962C8B-B14F-4D97-AF65-F5344CB8AC3E}">
         <p14:creationId xmlns:p14="http://schemas.microsoft.com/office/powerpoint/2010/main" val="3095838342"/>
+      </p:ext>
+    </p:extLst>
+  </p:cSld>
+  <p:clrMapOvr>
+    <a:masterClrMapping/>
+  </p:clrMapOvr>
+</p:sld>
+</file>
+
+<file path=ppt/slides/slide4.xml><?xml version="1.0" encoding="utf-8"?>
+<p:sld xmlns:a="http://schemas.openxmlformats.org/drawingml/2006/main" xmlns:r="http://schemas.openxmlformats.org/officeDocument/2006/relationships" xmlns:p="http://schemas.openxmlformats.org/presentationml/2006/main">
+  <p:cSld>
+    <p:spTree>
+      <p:nvGrpSpPr>
+        <p:cNvPr id="1" name="">
+          <a:extLst>
+            <a:ext uri="{FF2B5EF4-FFF2-40B4-BE49-F238E27FC236}">
+              <a16:creationId xmlns:a16="http://schemas.microsoft.com/office/drawing/2014/main" id="{0AFDA7EA-8AF0-378F-AD47-821B5A9AADCB}"/>
+            </a:ext>
+          </a:extLst>
+        </p:cNvPr>
+        <p:cNvGrpSpPr/>
+        <p:nvPr/>
+      </p:nvGrpSpPr>
+      <p:grpSpPr>
+        <a:xfrm>
+          <a:off x="0" y="0"/>
+          <a:ext cx="0" cy="0"/>
+          <a:chOff x="0" y="0"/>
+          <a:chExt cx="0" cy="0"/>
+        </a:xfrm>
+      </p:grpSpPr>
+      <p:sp>
+        <p:nvSpPr>
+          <p:cNvPr id="3" name="TextBox 2">
+            <a:extLst>
+              <a:ext uri="{FF2B5EF4-FFF2-40B4-BE49-F238E27FC236}">
+                <a16:creationId xmlns:a16="http://schemas.microsoft.com/office/drawing/2014/main" id="{ED2C19FF-8188-4B76-4453-07E38A89293E}"/>
+              </a:ext>
+            </a:extLst>
+          </p:cNvPr>
+          <p:cNvSpPr txBox="1"/>
+          <p:nvPr/>
+        </p:nvSpPr>
+        <p:spPr>
+          <a:xfrm>
+            <a:off x="217714" y="255046"/>
+            <a:ext cx="11756571" cy="355354"/>
+          </a:xfrm>
+          <a:prstGeom prst="rect">
+            <a:avLst/>
+          </a:prstGeom>
+          <a:noFill/>
+        </p:spPr>
+        <p:txBody>
+          <a:bodyPr wrap="square">
+            <a:spAutoFit/>
+          </a:bodyPr>
+          <a:lstStyle/>
+          <a:p>
+            <a:pPr>
+              <a:lnSpc>
+                <a:spcPct val="150000"/>
+              </a:lnSpc>
+              <a:buNone/>
+            </a:pPr>
+            <a:r>
+              <a:rPr lang="en-US" altLang="en-US" sz="1300">
+                <a:latin typeface="Arial" panose="020B0604020202020204" pitchFamily="34" charset="0"/>
+              </a:rPr>
+              <a:t>resources\views\admin\layouts\sidebar.blade.php</a:t>
+            </a:r>
+            <a:endParaRPr kumimoji="0" lang="en-US" altLang="en-US" sz="1300" b="0" i="0" u="none" strike="noStrike" cap="none" normalizeH="0" baseline="0">
+              <a:ln>
+                <a:noFill/>
+              </a:ln>
+              <a:solidFill>
+                <a:schemeClr val="tx1"/>
+              </a:solidFill>
+              <a:effectLst/>
+              <a:latin typeface="Arial" panose="020B0604020202020204" pitchFamily="34" charset="0"/>
+            </a:endParaRPr>
+          </a:p>
+        </p:txBody>
+      </p:sp>
+      <p:pic>
+        <p:nvPicPr>
+          <p:cNvPr id="4" name="Picture 3">
+            <a:extLst>
+              <a:ext uri="{FF2B5EF4-FFF2-40B4-BE49-F238E27FC236}">
+                <a16:creationId xmlns:a16="http://schemas.microsoft.com/office/drawing/2014/main" id="{6D956166-BD52-D542-45DB-13557343F7B2}"/>
+              </a:ext>
+            </a:extLst>
+          </p:cNvPr>
+          <p:cNvPicPr>
+            <a:picLocks noChangeAspect="1"/>
+          </p:cNvPicPr>
+          <p:nvPr/>
+        </p:nvPicPr>
+        <p:blipFill>
+          <a:blip r:embed="rId2"/>
+          <a:stretch>
+            <a:fillRect/>
+          </a:stretch>
+        </p:blipFill>
+        <p:spPr>
+          <a:xfrm>
+            <a:off x="3001818" y="769424"/>
+            <a:ext cx="9190182" cy="6088576"/>
+          </a:xfrm>
+          <a:prstGeom prst="rect">
+            <a:avLst/>
+          </a:prstGeom>
+        </p:spPr>
+      </p:pic>
+    </p:spTree>
+    <p:extLst>
+      <p:ext uri="{BB962C8B-B14F-4D97-AF65-F5344CB8AC3E}">
+        <p14:creationId xmlns:p14="http://schemas.microsoft.com/office/powerpoint/2010/main" val="2950590772"/>
+      </p:ext>
+    </p:extLst>
+  </p:cSld>
+  <p:clrMapOvr>
+    <a:masterClrMapping/>
+  </p:clrMapOvr>
+</p:sld>
+</file>
+
+<file path=ppt/slides/slide5.xml><?xml version="1.0" encoding="utf-8"?>
+<p:sld xmlns:a="http://schemas.openxmlformats.org/drawingml/2006/main" xmlns:r="http://schemas.openxmlformats.org/officeDocument/2006/relationships" xmlns:p="http://schemas.openxmlformats.org/presentationml/2006/main">
+  <p:cSld>
+    <p:spTree>
+      <p:nvGrpSpPr>
+        <p:cNvPr id="1" name="">
+          <a:extLst>
+            <a:ext uri="{FF2B5EF4-FFF2-40B4-BE49-F238E27FC236}">
+              <a16:creationId xmlns:a16="http://schemas.microsoft.com/office/drawing/2014/main" id="{168C0A5E-9A8E-1120-A6A3-81D647020638}"/>
+            </a:ext>
+          </a:extLst>
+        </p:cNvPr>
+        <p:cNvGrpSpPr/>
+        <p:nvPr/>
+      </p:nvGrpSpPr>
+      <p:grpSpPr>
+        <a:xfrm>
+          <a:off x="0" y="0"/>
+          <a:ext cx="0" cy="0"/>
+          <a:chOff x="0" y="0"/>
+          <a:chExt cx="0" cy="0"/>
+        </a:xfrm>
+      </p:grpSpPr>
+      <p:sp>
+        <p:nvSpPr>
+          <p:cNvPr id="3" name="TextBox 2">
+            <a:extLst>
+              <a:ext uri="{FF2B5EF4-FFF2-40B4-BE49-F238E27FC236}">
+                <a16:creationId xmlns:a16="http://schemas.microsoft.com/office/drawing/2014/main" id="{BEEF4DE1-BEAB-A269-EC33-4E014F61B53F}"/>
+              </a:ext>
+            </a:extLst>
+          </p:cNvPr>
+          <p:cNvSpPr txBox="1"/>
+          <p:nvPr/>
+        </p:nvSpPr>
+        <p:spPr>
+          <a:xfrm>
+            <a:off x="217714" y="255046"/>
+            <a:ext cx="11756571" cy="355354"/>
+          </a:xfrm>
+          <a:prstGeom prst="rect">
+            <a:avLst/>
+          </a:prstGeom>
+          <a:noFill/>
+        </p:spPr>
+        <p:txBody>
+          <a:bodyPr wrap="square">
+            <a:spAutoFit/>
+          </a:bodyPr>
+          <a:lstStyle/>
+          <a:p>
+            <a:pPr>
+              <a:lnSpc>
+                <a:spcPct val="150000"/>
+              </a:lnSpc>
+              <a:buNone/>
+            </a:pPr>
+            <a:r>
+              <a:rPr lang="en-US" altLang="en-US" sz="1300">
+                <a:latin typeface="Arial" panose="020B0604020202020204" pitchFamily="34" charset="0"/>
+              </a:rPr>
+              <a:t>routes\admin.php</a:t>
+            </a:r>
+            <a:endParaRPr kumimoji="0" lang="en-US" altLang="en-US" sz="1300" b="0" i="0" u="none" strike="noStrike" cap="none" normalizeH="0" baseline="0">
+              <a:ln>
+                <a:noFill/>
+              </a:ln>
+              <a:solidFill>
+                <a:schemeClr val="tx1"/>
+              </a:solidFill>
+              <a:effectLst/>
+              <a:latin typeface="Arial" panose="020B0604020202020204" pitchFamily="34" charset="0"/>
+            </a:endParaRPr>
+          </a:p>
+        </p:txBody>
+      </p:sp>
+      <p:pic>
+        <p:nvPicPr>
+          <p:cNvPr id="4" name="Picture 3">
+            <a:extLst>
+              <a:ext uri="{FF2B5EF4-FFF2-40B4-BE49-F238E27FC236}">
+                <a16:creationId xmlns:a16="http://schemas.microsoft.com/office/drawing/2014/main" id="{77853987-363D-B3F5-6F93-12EE8126336D}"/>
+              </a:ext>
+            </a:extLst>
+          </p:cNvPr>
+          <p:cNvPicPr>
+            <a:picLocks noChangeAspect="1"/>
+          </p:cNvPicPr>
+          <p:nvPr/>
+        </p:nvPicPr>
+        <p:blipFill>
+          <a:blip r:embed="rId2"/>
+          <a:stretch>
+            <a:fillRect/>
+          </a:stretch>
+        </p:blipFill>
+        <p:spPr>
+          <a:xfrm>
+            <a:off x="4017890" y="0"/>
+            <a:ext cx="8174110" cy="6858000"/>
+          </a:xfrm>
+          <a:prstGeom prst="rect">
+            <a:avLst/>
+          </a:prstGeom>
+        </p:spPr>
+      </p:pic>
+    </p:spTree>
+    <p:extLst>
+      <p:ext uri="{BB962C8B-B14F-4D97-AF65-F5344CB8AC3E}">
+        <p14:creationId xmlns:p14="http://schemas.microsoft.com/office/powerpoint/2010/main" val="1827531379"/>
+      </p:ext>
+    </p:extLst>
+  </p:cSld>
+  <p:clrMapOvr>
+    <a:masterClrMapping/>
+  </p:clrMapOvr>
+</p:sld>
+</file>
+
+<file path=ppt/slides/slide6.xml><?xml version="1.0" encoding="utf-8"?>
+<p:sld xmlns:a="http://schemas.openxmlformats.org/drawingml/2006/main" xmlns:r="http://schemas.openxmlformats.org/officeDocument/2006/relationships" xmlns:p="http://schemas.openxmlformats.org/presentationml/2006/main">
+  <p:cSld>
+    <p:spTree>
+      <p:nvGrpSpPr>
+        <p:cNvPr id="1" name="">
+          <a:extLst>
+            <a:ext uri="{FF2B5EF4-FFF2-40B4-BE49-F238E27FC236}">
+              <a16:creationId xmlns:a16="http://schemas.microsoft.com/office/drawing/2014/main" id="{640FB7A0-43F8-B9F0-3C64-F410B019EA36}"/>
+            </a:ext>
+          </a:extLst>
+        </p:cNvPr>
+        <p:cNvGrpSpPr/>
+        <p:nvPr/>
+      </p:nvGrpSpPr>
+      <p:grpSpPr>
+        <a:xfrm>
+          <a:off x="0" y="0"/>
+          <a:ext cx="0" cy="0"/>
+          <a:chOff x="0" y="0"/>
+          <a:chExt cx="0" cy="0"/>
+        </a:xfrm>
+      </p:grpSpPr>
+      <p:sp>
+        <p:nvSpPr>
+          <p:cNvPr id="3" name="TextBox 2">
+            <a:extLst>
+              <a:ext uri="{FF2B5EF4-FFF2-40B4-BE49-F238E27FC236}">
+                <a16:creationId xmlns:a16="http://schemas.microsoft.com/office/drawing/2014/main" id="{1E81EDA9-13D3-2F1E-8BE2-81B93EA9624D}"/>
+              </a:ext>
+            </a:extLst>
+          </p:cNvPr>
+          <p:cNvSpPr txBox="1"/>
+          <p:nvPr/>
+        </p:nvSpPr>
+        <p:spPr>
+          <a:xfrm>
+            <a:off x="217714" y="255046"/>
+            <a:ext cx="11756571" cy="655436"/>
+          </a:xfrm>
+          <a:prstGeom prst="rect">
+            <a:avLst/>
+          </a:prstGeom>
+          <a:noFill/>
+        </p:spPr>
+        <p:txBody>
+          <a:bodyPr wrap="square">
+            <a:spAutoFit/>
+          </a:bodyPr>
+          <a:lstStyle/>
+          <a:p>
+            <a:pPr>
+              <a:lnSpc>
+                <a:spcPct val="150000"/>
+              </a:lnSpc>
+              <a:buNone/>
+            </a:pPr>
+            <a:r>
+              <a:rPr lang="az-Latn-AZ" altLang="en-US" sz="1300" b="1">
+                <a:latin typeface="Arial" panose="020B0604020202020204" pitchFamily="34" charset="0"/>
+              </a:rPr>
+              <a:t>Vendor</a:t>
+            </a:r>
+            <a:r>
+              <a:rPr lang="az-Latn-AZ" altLang="en-US" sz="1300">
+                <a:latin typeface="Arial" panose="020B0604020202020204" pitchFamily="34" charset="0"/>
+              </a:rPr>
+              <a:t> üçün ayrıca </a:t>
+            </a:r>
+            <a:r>
+              <a:rPr lang="az-Latn-AZ" altLang="en-US" sz="1300" b="1">
+                <a:latin typeface="Arial" panose="020B0604020202020204" pitchFamily="34" charset="0"/>
+              </a:rPr>
+              <a:t>Create</a:t>
+            </a:r>
+            <a:r>
+              <a:rPr lang="az-Latn-AZ" altLang="en-US" sz="1300">
+                <a:latin typeface="Arial" panose="020B0604020202020204" pitchFamily="34" charset="0"/>
+              </a:rPr>
+              <a:t> səhifəsi yaratmırıq. Çünki çox vaxt gedəcək. Onun üçün sadəcə </a:t>
+            </a:r>
+            <a:r>
+              <a:rPr lang="az-Latn-AZ" altLang="en-US" sz="1300" b="1">
+                <a:latin typeface="Arial" panose="020B0604020202020204" pitchFamily="34" charset="0"/>
+              </a:rPr>
+              <a:t>UPDATE</a:t>
+            </a:r>
+            <a:r>
+              <a:rPr lang="az-Latn-AZ" altLang="en-US" sz="1300">
+                <a:latin typeface="Arial" panose="020B0604020202020204" pitchFamily="34" charset="0"/>
+              </a:rPr>
+              <a:t> edə biləcəyimiz</a:t>
+            </a:r>
+          </a:p>
+          <a:p>
+            <a:pPr>
+              <a:lnSpc>
+                <a:spcPct val="150000"/>
+              </a:lnSpc>
+              <a:buNone/>
+            </a:pPr>
+            <a:r>
+              <a:rPr kumimoji="0" lang="az-Latn-AZ" altLang="en-US" sz="1300" b="0" i="0" u="none" strike="noStrike" cap="none" normalizeH="0" baseline="0">
+                <a:ln>
+                  <a:noFill/>
+                </a:ln>
+                <a:solidFill>
+                  <a:schemeClr val="tx1"/>
+                </a:solidFill>
+                <a:effectLst/>
+                <a:latin typeface="Arial" panose="020B0604020202020204" pitchFamily="34" charset="0"/>
+              </a:rPr>
+              <a:t>bir şablon </a:t>
+            </a:r>
+            <a:r>
+              <a:rPr lang="az-Latn-AZ" altLang="en-US" sz="1300">
+                <a:latin typeface="Arial" panose="020B0604020202020204" pitchFamily="34" charset="0"/>
+              </a:rPr>
+              <a:t>yaradacağıq və </a:t>
+            </a:r>
+            <a:r>
+              <a:rPr lang="az-Latn-AZ" altLang="en-US" sz="1300" b="1">
+                <a:latin typeface="Arial" panose="020B0604020202020204" pitchFamily="34" charset="0"/>
+              </a:rPr>
+              <a:t>DB</a:t>
+            </a:r>
+            <a:r>
+              <a:rPr lang="az-Latn-AZ" altLang="en-US" sz="1300">
+                <a:latin typeface="Arial" panose="020B0604020202020204" pitchFamily="34" charset="0"/>
+              </a:rPr>
+              <a:t> -si </a:t>
+            </a:r>
+            <a:r>
+              <a:rPr lang="az-Latn-AZ" altLang="en-US" sz="1300" b="1">
+                <a:latin typeface="Arial" panose="020B0604020202020204" pitchFamily="34" charset="0"/>
+              </a:rPr>
+              <a:t>Seeder</a:t>
+            </a:r>
+            <a:r>
+              <a:rPr lang="az-Latn-AZ" altLang="en-US" sz="1300">
+                <a:latin typeface="Arial" panose="020B0604020202020204" pitchFamily="34" charset="0"/>
+              </a:rPr>
+              <a:t> ilə dolduracağıq.</a:t>
+            </a:r>
+            <a:endParaRPr kumimoji="0" lang="en-US" altLang="en-US" sz="1300" b="0" i="0" u="none" strike="noStrike" cap="none" normalizeH="0" baseline="0">
+              <a:ln>
+                <a:noFill/>
+              </a:ln>
+              <a:solidFill>
+                <a:schemeClr val="tx1"/>
+              </a:solidFill>
+              <a:effectLst/>
+              <a:latin typeface="Arial" panose="020B0604020202020204" pitchFamily="34" charset="0"/>
+            </a:endParaRPr>
+          </a:p>
+        </p:txBody>
+      </p:sp>
+      <p:pic>
+        <p:nvPicPr>
+          <p:cNvPr id="4" name="Picture 3">
+            <a:extLst>
+              <a:ext uri="{FF2B5EF4-FFF2-40B4-BE49-F238E27FC236}">
+                <a16:creationId xmlns:a16="http://schemas.microsoft.com/office/drawing/2014/main" id="{CB8DD673-F51D-6146-CCED-C0905F83B77E}"/>
+              </a:ext>
+            </a:extLst>
+          </p:cNvPr>
+          <p:cNvPicPr>
+            <a:picLocks noChangeAspect="1"/>
+          </p:cNvPicPr>
+          <p:nvPr/>
+        </p:nvPicPr>
+        <p:blipFill>
+          <a:blip r:embed="rId2"/>
+          <a:stretch>
+            <a:fillRect/>
+          </a:stretch>
+        </p:blipFill>
+        <p:spPr>
+          <a:xfrm>
+            <a:off x="10144836" y="0"/>
+            <a:ext cx="2047164" cy="6858000"/>
+          </a:xfrm>
+          <a:prstGeom prst="rect">
+            <a:avLst/>
+          </a:prstGeom>
+        </p:spPr>
+      </p:pic>
+    </p:spTree>
+    <p:extLst>
+      <p:ext uri="{BB962C8B-B14F-4D97-AF65-F5344CB8AC3E}">
+        <p14:creationId xmlns:p14="http://schemas.microsoft.com/office/powerpoint/2010/main" val="981651402"/>
+      </p:ext>
+    </p:extLst>
+  </p:cSld>
+  <p:clrMapOvr>
+    <a:masterClrMapping/>
+  </p:clrMapOvr>
+</p:sld>
+</file>
+
+<file path=ppt/slides/slide7.xml><?xml version="1.0" encoding="utf-8"?>
+<p:sld xmlns:a="http://schemas.openxmlformats.org/drawingml/2006/main" xmlns:r="http://schemas.openxmlformats.org/officeDocument/2006/relationships" xmlns:p="http://schemas.openxmlformats.org/presentationml/2006/main">
+  <p:cSld>
+    <p:spTree>
+      <p:nvGrpSpPr>
+        <p:cNvPr id="1" name="">
+          <a:extLst>
+            <a:ext uri="{FF2B5EF4-FFF2-40B4-BE49-F238E27FC236}">
+              <a16:creationId xmlns:a16="http://schemas.microsoft.com/office/drawing/2014/main" id="{CD4AD388-50DB-51F2-8551-ECB2FD4BAD71}"/>
+            </a:ext>
+          </a:extLst>
+        </p:cNvPr>
+        <p:cNvGrpSpPr/>
+        <p:nvPr/>
+      </p:nvGrpSpPr>
+      <p:grpSpPr>
+        <a:xfrm>
+          <a:off x="0" y="0"/>
+          <a:ext cx="0" cy="0"/>
+          <a:chOff x="0" y="0"/>
+          <a:chExt cx="0" cy="0"/>
+        </a:xfrm>
+      </p:grpSpPr>
+      <p:pic>
+        <p:nvPicPr>
+          <p:cNvPr id="4" name="Picture 3">
+            <a:extLst>
+              <a:ext uri="{FF2B5EF4-FFF2-40B4-BE49-F238E27FC236}">
+                <a16:creationId xmlns:a16="http://schemas.microsoft.com/office/drawing/2014/main" id="{20FCBBDF-AC0A-D8D0-B31F-36D64A0DC6B2}"/>
+              </a:ext>
+            </a:extLst>
+          </p:cNvPr>
+          <p:cNvPicPr>
+            <a:picLocks noChangeAspect="1"/>
+          </p:cNvPicPr>
+          <p:nvPr/>
+        </p:nvPicPr>
+        <p:blipFill>
+          <a:blip r:embed="rId2"/>
+          <a:stretch>
+            <a:fillRect/>
+          </a:stretch>
+        </p:blipFill>
+        <p:spPr>
+          <a:xfrm>
+            <a:off x="6476202" y="313412"/>
+            <a:ext cx="5715798" cy="6544588"/>
+          </a:xfrm>
+          <a:prstGeom prst="rect">
+            <a:avLst/>
+          </a:prstGeom>
+        </p:spPr>
+      </p:pic>
+      <p:sp>
+        <p:nvSpPr>
+          <p:cNvPr id="5" name="TextBox 4">
+            <a:extLst>
+              <a:ext uri="{FF2B5EF4-FFF2-40B4-BE49-F238E27FC236}">
+                <a16:creationId xmlns:a16="http://schemas.microsoft.com/office/drawing/2014/main" id="{7EB7C558-F146-5719-1D0F-72249F2A50BF}"/>
+              </a:ext>
+            </a:extLst>
+          </p:cNvPr>
+          <p:cNvSpPr txBox="1"/>
+          <p:nvPr/>
+        </p:nvSpPr>
+        <p:spPr>
+          <a:xfrm>
+            <a:off x="217714" y="255046"/>
+            <a:ext cx="11756571" cy="355354"/>
+          </a:xfrm>
+          <a:prstGeom prst="rect">
+            <a:avLst/>
+          </a:prstGeom>
+          <a:noFill/>
+        </p:spPr>
+        <p:txBody>
+          <a:bodyPr wrap="square">
+            <a:spAutoFit/>
+          </a:bodyPr>
+          <a:lstStyle/>
+          <a:p>
+            <a:pPr>
+              <a:lnSpc>
+                <a:spcPct val="150000"/>
+              </a:lnSpc>
+              <a:buNone/>
+            </a:pPr>
+            <a:r>
+              <a:rPr lang="en-US" altLang="en-US" sz="1300">
+                <a:latin typeface="Arial" panose="020B0604020202020204" pitchFamily="34" charset="0"/>
+              </a:rPr>
+              <a:t>database\migrations\2025_09_08_121247_create_vendors_table.php</a:t>
+            </a:r>
+            <a:endParaRPr kumimoji="0" lang="en-US" altLang="en-US" sz="1300" b="0" i="0" u="none" strike="noStrike" cap="none" normalizeH="0" baseline="0">
+              <a:ln>
+                <a:noFill/>
+              </a:ln>
+              <a:solidFill>
+                <a:schemeClr val="tx1"/>
+              </a:solidFill>
+              <a:effectLst/>
+              <a:latin typeface="Arial" panose="020B0604020202020204" pitchFamily="34" charset="0"/>
+            </a:endParaRPr>
+          </a:p>
+        </p:txBody>
+      </p:sp>
+    </p:spTree>
+    <p:extLst>
+      <p:ext uri="{BB962C8B-B14F-4D97-AF65-F5344CB8AC3E}">
+        <p14:creationId xmlns:p14="http://schemas.microsoft.com/office/powerpoint/2010/main" val="2569276444"/>
+      </p:ext>
+    </p:extLst>
+  </p:cSld>
+  <p:clrMapOvr>
+    <a:masterClrMapping/>
+  </p:clrMapOvr>
+</p:sld>
+</file>
+
+<file path=ppt/slides/slide8.xml><?xml version="1.0" encoding="utf-8"?>
+<p:sld xmlns:a="http://schemas.openxmlformats.org/drawingml/2006/main" xmlns:r="http://schemas.openxmlformats.org/officeDocument/2006/relationships" xmlns:p="http://schemas.openxmlformats.org/presentationml/2006/main">
+  <p:cSld>
+    <p:spTree>
+      <p:nvGrpSpPr>
+        <p:cNvPr id="1" name="">
+          <a:extLst>
+            <a:ext uri="{FF2B5EF4-FFF2-40B4-BE49-F238E27FC236}">
+              <a16:creationId xmlns:a16="http://schemas.microsoft.com/office/drawing/2014/main" id="{90D8F2EB-BCA0-4A42-2174-82C7C55FBF1B}"/>
+            </a:ext>
+          </a:extLst>
+        </p:cNvPr>
+        <p:cNvGrpSpPr/>
+        <p:nvPr/>
+      </p:nvGrpSpPr>
+      <p:grpSpPr>
+        <a:xfrm>
+          <a:off x="0" y="0"/>
+          <a:ext cx="0" cy="0"/>
+          <a:chOff x="0" y="0"/>
+          <a:chExt cx="0" cy="0"/>
+        </a:xfrm>
+      </p:grpSpPr>
+      <p:sp>
+        <p:nvSpPr>
+          <p:cNvPr id="3" name="TextBox 2">
+            <a:extLst>
+              <a:ext uri="{FF2B5EF4-FFF2-40B4-BE49-F238E27FC236}">
+                <a16:creationId xmlns:a16="http://schemas.microsoft.com/office/drawing/2014/main" id="{4B19739A-0D6C-861C-EF54-00490756BAEC}"/>
+              </a:ext>
+            </a:extLst>
+          </p:cNvPr>
+          <p:cNvSpPr txBox="1"/>
+          <p:nvPr/>
+        </p:nvSpPr>
+        <p:spPr>
+          <a:xfrm>
+            <a:off x="217714" y="255046"/>
+            <a:ext cx="11756571" cy="355354"/>
+          </a:xfrm>
+          <a:prstGeom prst="rect">
+            <a:avLst/>
+          </a:prstGeom>
+          <a:noFill/>
+        </p:spPr>
+        <p:txBody>
+          <a:bodyPr wrap="square">
+            <a:spAutoFit/>
+          </a:bodyPr>
+          <a:lstStyle/>
+          <a:p>
+            <a:pPr>
+              <a:lnSpc>
+                <a:spcPct val="150000"/>
+              </a:lnSpc>
+              <a:buNone/>
+            </a:pPr>
+            <a:r>
+              <a:rPr kumimoji="0" lang="en-US" altLang="en-US" sz="1300" b="0" i="0" u="none" strike="noStrike" cap="none" normalizeH="0" baseline="0">
+                <a:ln>
+                  <a:noFill/>
+                </a:ln>
+                <a:solidFill>
+                  <a:schemeClr val="tx1"/>
+                </a:solidFill>
+                <a:effectLst/>
+                <a:latin typeface="Arial" panose="020B0604020202020204" pitchFamily="34" charset="0"/>
+              </a:rPr>
+              <a:t>.</a:t>
+            </a:r>
+          </a:p>
+        </p:txBody>
+      </p:sp>
+      <p:pic>
+        <p:nvPicPr>
+          <p:cNvPr id="4" name="Picture 3">
+            <a:extLst>
+              <a:ext uri="{FF2B5EF4-FFF2-40B4-BE49-F238E27FC236}">
+                <a16:creationId xmlns:a16="http://schemas.microsoft.com/office/drawing/2014/main" id="{4FFE03E4-69B8-91E2-7582-CDEAD2E841FD}"/>
+              </a:ext>
+            </a:extLst>
+          </p:cNvPr>
+          <p:cNvPicPr>
+            <a:picLocks noChangeAspect="1"/>
+          </p:cNvPicPr>
+          <p:nvPr/>
+        </p:nvPicPr>
+        <p:blipFill>
+          <a:blip r:embed="rId2"/>
+          <a:stretch>
+            <a:fillRect/>
+          </a:stretch>
+        </p:blipFill>
+        <p:spPr>
+          <a:xfrm>
+            <a:off x="1703511" y="5047997"/>
+            <a:ext cx="10488489" cy="1810003"/>
+          </a:xfrm>
+          <a:prstGeom prst="rect">
+            <a:avLst/>
+          </a:prstGeom>
+        </p:spPr>
+      </p:pic>
+    </p:spTree>
+    <p:extLst>
+      <p:ext uri="{BB962C8B-B14F-4D97-AF65-F5344CB8AC3E}">
+        <p14:creationId xmlns:p14="http://schemas.microsoft.com/office/powerpoint/2010/main" val="2898371738"/>
+      </p:ext>
+    </p:extLst>
+  </p:cSld>
+  <p:clrMapOvr>
+    <a:masterClrMapping/>
+  </p:clrMapOvr>
+</p:sld>
+</file>
+
+<file path=ppt/slides/slide9.xml><?xml version="1.0" encoding="utf-8"?>
+<p:sld xmlns:a="http://schemas.openxmlformats.org/drawingml/2006/main" xmlns:r="http://schemas.openxmlformats.org/officeDocument/2006/relationships" xmlns:p="http://schemas.openxmlformats.org/presentationml/2006/main">
+  <p:cSld>
+    <p:spTree>
+      <p:nvGrpSpPr>
+        <p:cNvPr id="1" name="">
+          <a:extLst>
+            <a:ext uri="{FF2B5EF4-FFF2-40B4-BE49-F238E27FC236}">
+              <a16:creationId xmlns:a16="http://schemas.microsoft.com/office/drawing/2014/main" id="{2FE0FDD0-C533-1C3E-A3A9-22E32968AE86}"/>
+            </a:ext>
+          </a:extLst>
+        </p:cNvPr>
+        <p:cNvGrpSpPr/>
+        <p:nvPr/>
+      </p:nvGrpSpPr>
+      <p:grpSpPr>
+        <a:xfrm>
+          <a:off x="0" y="0"/>
+          <a:ext cx="0" cy="0"/>
+          <a:chOff x="0" y="0"/>
+          <a:chExt cx="0" cy="0"/>
+        </a:xfrm>
+      </p:grpSpPr>
+      <p:sp>
+        <p:nvSpPr>
+          <p:cNvPr id="3" name="TextBox 2">
+            <a:extLst>
+              <a:ext uri="{FF2B5EF4-FFF2-40B4-BE49-F238E27FC236}">
+                <a16:creationId xmlns:a16="http://schemas.microsoft.com/office/drawing/2014/main" id="{74594229-96D6-3EDA-E472-332E47F5AD74}"/>
+              </a:ext>
+            </a:extLst>
+          </p:cNvPr>
+          <p:cNvSpPr txBox="1"/>
+          <p:nvPr/>
+        </p:nvSpPr>
+        <p:spPr>
+          <a:xfrm>
+            <a:off x="217714" y="255046"/>
+            <a:ext cx="11756571" cy="355354"/>
+          </a:xfrm>
+          <a:prstGeom prst="rect">
+            <a:avLst/>
+          </a:prstGeom>
+          <a:noFill/>
+        </p:spPr>
+        <p:txBody>
+          <a:bodyPr wrap="square">
+            <a:spAutoFit/>
+          </a:bodyPr>
+          <a:lstStyle/>
+          <a:p>
+            <a:pPr>
+              <a:lnSpc>
+                <a:spcPct val="150000"/>
+              </a:lnSpc>
+              <a:buNone/>
+            </a:pPr>
+            <a:r>
+              <a:rPr lang="en-US" altLang="en-US" sz="1300">
+                <a:latin typeface="Arial" panose="020B0604020202020204" pitchFamily="34" charset="0"/>
+              </a:rPr>
+              <a:t>app\Http\Controllers\Backend\AdminVendorProfileController.php</a:t>
+            </a:r>
+            <a:endParaRPr kumimoji="0" lang="en-US" altLang="en-US" sz="1300" b="0" i="0" u="none" strike="noStrike" cap="none" normalizeH="0" baseline="0">
+              <a:ln>
+                <a:noFill/>
+              </a:ln>
+              <a:solidFill>
+                <a:schemeClr val="tx1"/>
+              </a:solidFill>
+              <a:effectLst/>
+              <a:latin typeface="Arial" panose="020B0604020202020204" pitchFamily="34" charset="0"/>
+            </a:endParaRPr>
+          </a:p>
+        </p:txBody>
+      </p:sp>
+      <p:pic>
+        <p:nvPicPr>
+          <p:cNvPr id="4" name="Picture 3">
+            <a:extLst>
+              <a:ext uri="{FF2B5EF4-FFF2-40B4-BE49-F238E27FC236}">
+                <a16:creationId xmlns:a16="http://schemas.microsoft.com/office/drawing/2014/main" id="{0EB0D87A-4772-1AB5-E4A0-04634E195568}"/>
+              </a:ext>
+            </a:extLst>
+          </p:cNvPr>
+          <p:cNvPicPr>
+            <a:picLocks noChangeAspect="1"/>
+          </p:cNvPicPr>
+          <p:nvPr/>
+        </p:nvPicPr>
+        <p:blipFill>
+          <a:blip r:embed="rId2"/>
+          <a:stretch>
+            <a:fillRect/>
+          </a:stretch>
+        </p:blipFill>
+        <p:spPr>
+          <a:xfrm>
+            <a:off x="7595152" y="0"/>
+            <a:ext cx="4596848" cy="6858000"/>
+          </a:xfrm>
+          <a:prstGeom prst="rect">
+            <a:avLst/>
+          </a:prstGeom>
+        </p:spPr>
+      </p:pic>
+    </p:spTree>
+    <p:extLst>
+      <p:ext uri="{BB962C8B-B14F-4D97-AF65-F5344CB8AC3E}">
+        <p14:creationId xmlns:p14="http://schemas.microsoft.com/office/powerpoint/2010/main" val="1410445986"/>
       </p:ext>
     </p:extLst>
   </p:cSld>

</xml_diff>